<commit_message>
documentation tidy-up: formatting consistency across docs and deliverables
</commit_message>
<xml_diff>
--- a/docs/deliverables/Kaoma_Paradata_Presentation.pptx
+++ b/docs/deliverables/Kaoma_Paradata_Presentation.pptx
@@ -559,7 +559,7 @@
           <a:p>
             <a:r>
               <a:rPr lang="en-US" dirty="0"/>
-              <a:t>This simulated output shows what the system produces: each interview gets an anomaly score based on combined IQR and rule flags. Interviewers with high scores are prioritized for back-check verification — dramatically more efficient than manual review.</a:t>
+              <a:t>This simulated output shows what the system produces: each interview gets an anomaly score based on combined IQR and rule flags. Interviewers with high scores are prioritized for back-check verification, dramatically more efficient than manual review.</a:t>
             </a:r>
           </a:p>
         </p:txBody>
@@ -646,7 +646,7 @@
           <a:p>
             <a:r>
               <a:rPr lang="en-US" dirty="0"/>
-              <a:t>The contrast is stark: from one metric and 5% coverage to 40 features and 100% automated coverage. This is the practical impact of the system — not just academic improvement, but operational transformation.</a:t>
+              <a:t>The contrast is stark: from one metric and 5% coverage to 40 features and 100% automated coverage. This is the practical impact of the system, not just academic improvement, but operational transformation.</a:t>
             </a:r>
           </a:p>
         </p:txBody>
@@ -820,7 +820,7 @@
           <a:p>
             <a:r>
               <a:rPr lang="en-US" dirty="0"/>
-              <a:t>Limitations are acknowledged transparently — a mark of rigorous research. The future work roadmap shows a clear pathway to extension: real data validation, ML integration, and open-source release.</a:t>
+              <a:t>Limitations are acknowledged transparently, a mark of rigorous research. The future work roadmap shows a clear pathway to extension: real data validation, ML integration, and open-source release.</a:t>
             </a:r>
           </a:p>
         </p:txBody>
@@ -907,7 +907,7 @@
           <a:p>
             <a:r>
               <a:rPr lang="en-US" dirty="0"/>
-              <a:t>Close with confidence. This project bridges a clear gap: theoretical survey methodology research has identified the value of paradata, but no automated, cross-platform tool exists to operationalize it. This system changes that. Thank you — questions welcome.</a:t>
+              <a:t>Close with confidence. This project bridges a clear gap: theoretical survey methodology research has identified the value of paradata, but no automated, cross-platform tool exists to operationalize it. This system changes that. Thank you, questions welcome.</a:t>
             </a:r>
           </a:p>
         </p:txBody>
@@ -994,7 +994,7 @@
           <a:p>
             <a:r>
               <a:rPr lang="en-US" dirty="0"/>
-              <a:t>Survey data is the foundation of policy decisions — but fabricated responses, rushed interviews, and inattentive enumerators undermine quality. Current methods only check total time, missing the behavioral fingerprints hidden in paradata.</a:t>
+              <a:t>Survey data is the foundation of policy decisions, but fabricated responses, rushed interviews, and inattentive enumerators undermine quality. Current methods only check total time, missing the behavioral fingerprints hidden in paradata.</a:t>
             </a:r>
           </a:p>
         </p:txBody>
@@ -1081,7 +1081,7 @@
           <a:p>
             <a:r>
               <a:rPr lang="en-US" dirty="0"/>
-              <a:t>Paradata is the 'how' behind the survey. Platforms like SurveyCTO and ODK log every interaction — but in incompatible formats. This project bridges that gap.</a:t>
+              <a:t>Paradata is the 'how' behind the survey. Platforms like SurveyCTO and ODK log every interaction, but in incompatible formats. This project bridges that gap.</a:t>
             </a:r>
           </a:p>
         </p:txBody>
@@ -1168,7 +1168,7 @@
           <a:p>
             <a:r>
               <a:rPr lang="en-US" dirty="0"/>
-              <a:t>The status quo is fragile. Survey organizations rely on total interview time as their main quality signal — but that single metric misses fabricated responses, rushed answers, and inattentive navigation that paradata can reveal.</a:t>
+              <a:t>The status quo is fragile. Survey organizations rely on total interview time as their main quality signal, but that single metric misses fabricated responses, rushed answers, and inattentive navigation that paradata can reveal.</a:t>
             </a:r>
           </a:p>
         </p:txBody>
@@ -1342,7 +1342,7 @@
           <a:p>
             <a:r>
               <a:rPr lang="en-US" dirty="0"/>
-              <a:t>The architecture is deliberately modular. Raw logs enter, get normalized through platform-specific parsers into a Common Intermediate Representation, then flow through extraction, characterization, and detection layers — producing quality reports.</a:t>
+              <a:t>The architecture is deliberately modular. Raw logs enter, get normalized through platform-specific parsers into a Common Intermediate Representation, then flow through extraction, characterization, and detection layers, producing quality reports.</a:t>
             </a:r>
           </a:p>
         </p:txBody>
@@ -2698,7 +2698,7 @@
                   <a:srgbClr val="E0E6F0"/>
                 </a:solidFill>
               </a:rPr>
-              <a:t>No labelled real-world paradata exists. Synthetic generation enables controlled injection of known anomaly types with ground-truth labels — enabling rigorous, reproducible evaluation.</a:t>
+              <a:t>No labelled real-world paradata exists. Synthetic generation enables controlled injection of known anomaly types with ground-truth labels, enabling rigorous, reproducible evaluation.</a:t>
             </a:r>
             <a:endParaRPr lang="en-US" sz="1100" dirty="0"/>
           </a:p>
@@ -3604,7 +3604,7 @@
                   <a:srgbClr val="00B4D8"/>
                 </a:solidFill>
               </a:rPr>
-              <a:t>Level 1 — Feature Validation</a:t>
+              <a:t>Level 1: Feature Validation</a:t>
             </a:r>
             <a:endParaRPr lang="en-US" sz="1400" dirty="0"/>
           </a:p>
@@ -3740,7 +3740,7 @@
                   <a:srgbClr val="06D6A0"/>
                 </a:solidFill>
               </a:rPr>
-              <a:t>Level 2 — Detection Performance</a:t>
+              <a:t>Level 2: Detection Performance</a:t>
             </a:r>
             <a:endParaRPr lang="en-US" sz="1400" dirty="0"/>
           </a:p>
@@ -4090,7 +4090,7 @@
                   <a:srgbClr val="E0E6F0"/>
                 </a:solidFill>
               </a:rPr>
-              <a:t>Duration-only threshold — industry standard; single-metric IQR on total interview time</a:t>
+              <a:t>Duration-only threshold, industry standard; single-metric IQR on total interview time</a:t>
             </a:r>
             <a:endParaRPr lang="en-US" sz="1150" dirty="0"/>
           </a:p>
@@ -4134,7 +4134,7 @@
                   <a:srgbClr val="E0E6F0"/>
                 </a:solidFill>
               </a:rPr>
-              <a:t>Zero back-nav flag only — minimal rule-based approach</a:t>
+              <a:t>Zero back-nav flag only, minimal rule-based approach</a:t>
             </a:r>
             <a:endParaRPr lang="en-US" sz="1150" dirty="0"/>
           </a:p>
@@ -4369,7 +4369,7 @@
                   <a:srgbClr val="FFFFFF"/>
                 </a:solidFill>
               </a:rPr>
-              <a:t>Anomaly Detection — Simulated Output</a:t>
+              <a:t>Anomaly Detection: Simulated Output</a:t>
             </a:r>
             <a:endParaRPr lang="en-US" sz="2400" dirty="0"/>
           </a:p>
@@ -6133,7 +6133,7 @@
                   <a:srgbClr val="06D6A0"/>
                 </a:solidFill>
               </a:rPr>
-              <a:t>🟢  CLEAN: Score 0–1  </a:t>
+              <a:t>CLEAN: Score 0–1  </a:t>
             </a:r>
             <a:endParaRPr lang="en-US" sz="1000" dirty="0"/>
           </a:p>
@@ -6169,7 +6169,7 @@
                   <a:srgbClr val="FFD166"/>
                 </a:solidFill>
               </a:rPr>
-              <a:t>🟡  REVIEW: Score 2–4  </a:t>
+              <a:t>REVIEW: Score 2–4  </a:t>
             </a:r>
             <a:endParaRPr lang="en-US" sz="1000" dirty="0"/>
           </a:p>
@@ -6205,7 +6205,7 @@
                   <a:srgbClr val="FF4D6D"/>
                 </a:solidFill>
               </a:rPr>
-              <a:t>🔴  FLAGGED: Score 5+</a:t>
+              <a:t>FLAGGED: Score 5+</a:t>
             </a:r>
             <a:endParaRPr lang="en-US" sz="1000" dirty="0"/>
           </a:p>
@@ -6404,7 +6404,7 @@
                   <a:srgbClr val="FFFFFF"/>
                 </a:solidFill>
               </a:rPr>
-              <a:t>Before vs After — QA Intelligence</a:t>
+              <a:t>Before vs After: QA Intelligence</a:t>
             </a:r>
             <a:endParaRPr lang="en-US" sz="2600" dirty="0"/>
           </a:p>
@@ -7581,7 +7581,7 @@
                   <a:srgbClr val="E0E6F0"/>
                 </a:solidFill>
               </a:rPr>
-              <a:t>IQR thresholding makes no normality assumption — ideal for right-skewed, heavy-tailed response time distributions. Z-scores would fail here.</a:t>
+              <a:t>IQR thresholding makes no normality assumption, ideal for right-skewed, heavy-tailed response time distributions. Z-scores would fail here.</a:t>
             </a:r>
             <a:endParaRPr lang="en-US" sz="1050" dirty="0"/>
           </a:p>
@@ -7905,7 +7905,7 @@
                   <a:srgbClr val="E0E6F0"/>
                 </a:solidFill>
               </a:rPr>
-              <a:t>Features span question, section, and survey levels. A suspicious pattern at any level — from a single field to the full interview arc — contributes to the anomaly score.</a:t>
+              <a:t>Features span question, section, and survey levels. A suspicious pattern at any level, from a single field to the full interview arc, contributes to the anomaly score.</a:t>
             </a:r>
             <a:endParaRPr lang="en-US" sz="1050" dirty="0"/>
           </a:p>
@@ -9349,7 +9349,7 @@
                   <a:srgbClr val="00B4D8"/>
                 </a:solidFill>
               </a:rPr>
-              <a:t>✦  </a:t>
+              <a:t>•  </a:t>
             </a:r>
             <a:r>
               <a:rPr lang="en-US" sz="1200" dirty="0">
@@ -9393,7 +9393,7 @@
                   <a:srgbClr val="00B4D8"/>
                 </a:solidFill>
               </a:rPr>
-              <a:t>✦  </a:t>
+              <a:t>•  </a:t>
             </a:r>
             <a:r>
               <a:rPr lang="en-US" sz="1200" dirty="0">
@@ -9437,7 +9437,7 @@
                   <a:srgbClr val="00B4D8"/>
                 </a:solidFill>
               </a:rPr>
-              <a:t>✦  </a:t>
+              <a:t>•  </a:t>
             </a:r>
             <a:r>
               <a:rPr lang="en-US" sz="1200" dirty="0">
@@ -9481,7 +9481,7 @@
                   <a:srgbClr val="00B4D8"/>
                 </a:solidFill>
               </a:rPr>
-              <a:t>✦  </a:t>
+              <a:t>•  </a:t>
             </a:r>
             <a:r>
               <a:rPr lang="en-US" sz="1200" dirty="0">
@@ -9489,7 +9489,7 @@
                   <a:srgbClr val="E0E6F0"/>
                 </a:solidFill>
               </a:rPr>
-              <a:t>Precision ≥ 0.80 · Recall ≥ 0.75 — validated against labelled synthetic data</a:t>
+              <a:t>Precision ≥ 0.80 · Recall ≥ 0.75, validated against labelled synthetic data</a:t>
             </a:r>
             <a:endParaRPr lang="en-US" sz="1200" dirty="0"/>
           </a:p>
@@ -9525,7 +9525,7 @@
                   <a:srgbClr val="00B4D8"/>
                 </a:solidFill>
               </a:rPr>
-              <a:t>✦  </a:t>
+              <a:t>•  </a:t>
             </a:r>
             <a:r>
               <a:rPr lang="en-US" sz="1200" dirty="0">
@@ -10204,7 +10204,7 @@
                   <a:srgbClr val="E0E6F0"/>
                 </a:solidFill>
               </a:rPr>
-              <a:t>SurveyCTO &amp; ODK use different formats — no standard tool exists</a:t>
+              <a:t>SurveyCTO &amp; ODK use different formats, no standard tool exists</a:t>
             </a:r>
             <a:endParaRPr lang="en-US" sz="1200" dirty="0"/>
           </a:p>
@@ -10267,7 +10267,7 @@
                   <a:srgbClr val="8899BB"/>
                 </a:solidFill>
               </a:rPr>
-              <a:t>🔍  Current QA methods detect only </a:t>
+              <a:t>Current QA methods detect only </a:t>
             </a:r>
             <a:r>
               <a:rPr lang="en-US" sz="1300" b="1" dirty="0">
@@ -10283,7 +10283,7 @@
                   <a:srgbClr val="8899BB"/>
                 </a:solidFill>
               </a:rPr>
-              <a:t> — leaving </a:t>
+              <a:t>, leaving </a:t>
             </a:r>
             <a:r>
               <a:rPr lang="en-US" sz="1300" b="1" dirty="0">
@@ -10616,7 +10616,7 @@
                   <a:srgbClr val="E0E6F0"/>
                 </a:solidFill>
               </a:rPr>
-              <a:t>Captured automatically by digital survey platforms during data collection — not the survey answers, but HOW those answers were given.</a:t>
+              <a:t>Captured automatically by digital survey platforms during data collection, not the survey answers, but HOW those answers were given.</a:t>
             </a:r>
             <a:endParaRPr lang="en-US" sz="1200" dirty="0"/>
           </a:p>
@@ -11098,7 +11098,7 @@
                   <a:srgbClr val="8899BB"/>
                 </a:solidFill>
               </a:rPr>
-              <a:t>"Rich behavioral intelligence hidden in plain sight — unused."</a:t>
+              <a:t>"Rich behavioral intelligence hidden in plain sight, unused."</a:t>
             </a:r>
             <a:endParaRPr lang="en-US" sz="1100" dirty="0"/>
           </a:p>
@@ -11693,7 +11693,7 @@
                   <a:srgbClr val="8899BB"/>
                 </a:solidFill>
               </a:rPr>
-              <a:t>Expensive, slow, unscalable — covers &lt;5% of interviews</a:t>
+              <a:t>Expensive, slow, unscalable, covers &lt;5% of interviews</a:t>
             </a:r>
             <a:endParaRPr lang="en-US" sz="1100" dirty="0"/>
           </a:p>
@@ -12116,7 +12116,7 @@
                   <a:srgbClr val="FF4D6D"/>
                 </a:solidFill>
               </a:rPr>
-              <a:t>❌  No existing tool automates multi-feature, cross-platform paradata analysis at scale.</a:t>
+              <a:t>No existing tool automates multi-feature, cross-platform paradata analysis at scale.</a:t>
             </a:r>
             <a:endParaRPr lang="en-US" sz="1100" dirty="0"/>
           </a:p>
@@ -12972,7 +12972,7 @@
                   <a:srgbClr val="E0E6F0"/>
                 </a:solidFill>
               </a:rPr>
-              <a:t>Aim:  Design and implement an automated pipeline for extracting, cataloguing, and analyzing timing-based paradata features from SurveyCTO and ODK audit logs — supporting scalable survey quality assessment.</a:t>
+              <a:t>Aim:  Design and implement an automated pipeline for extracting, cataloguing, and analyzing timing-based paradata features from SurveyCTO and ODK audit logs, supporting scalable survey quality assessment.</a:t>
             </a:r>
             <a:endParaRPr lang="en-US" sz="1100" dirty="0"/>
           </a:p>
@@ -17618,7 +17618,7 @@
                   <a:srgbClr val="FF4D6D"/>
                 </a:solidFill>
               </a:rPr>
-              <a:t>Layer 1 — Statistical IQR Detection</a:t>
+              <a:t>Layer 1: Statistical IQR Detection</a:t>
             </a:r>
             <a:endParaRPr lang="en-US" sz="1300" dirty="0"/>
           </a:p>
@@ -17833,7 +17833,7 @@
                   <a:srgbClr val="FFD166"/>
                 </a:solidFill>
               </a:rPr>
-              <a:t>Layer 2 — Rule-Based Domain Logic</a:t>
+              <a:t>Layer 2: Rule-Based Domain Logic</a:t>
             </a:r>
             <a:endParaRPr lang="en-US" sz="1300" dirty="0"/>
           </a:p>
@@ -17869,7 +17869,7 @@
                   <a:srgbClr val="FFD166"/>
                 </a:solidFill>
               </a:rPr>
-              <a:t>⚡  </a:t>
+              <a:t>•  </a:t>
             </a:r>
             <a:r>
               <a:rPr lang="en-US" sz="1100" dirty="0">
@@ -17913,7 +17913,7 @@
                   <a:srgbClr val="FFD166"/>
                 </a:solidFill>
               </a:rPr>
-              <a:t>⚡  </a:t>
+              <a:t>•  </a:t>
             </a:r>
             <a:r>
               <a:rPr lang="en-US" sz="1100" dirty="0">
@@ -17957,7 +17957,7 @@
                   <a:srgbClr val="FFD166"/>
                 </a:solidFill>
               </a:rPr>
-              <a:t>⚡  </a:t>
+              <a:t>•  </a:t>
             </a:r>
             <a:r>
               <a:rPr lang="en-US" sz="1100" dirty="0">
@@ -18001,7 +18001,7 @@
                   <a:srgbClr val="FFD166"/>
                 </a:solidFill>
               </a:rPr>
-              <a:t>⚡  </a:t>
+              <a:t>•  </a:t>
             </a:r>
             <a:r>
               <a:rPr lang="en-US" sz="1100" dirty="0">

</xml_diff>

<commit_message>
redesign the system architecture slide as a boxes-and-arrows diagram
</commit_message>
<xml_diff>
--- a/docs/deliverables/Kaoma_Paradata_Presentation.pptx
+++ b/docs/deliverables/Kaoma_Paradata_Presentation.pptx
@@ -11164,12 +11164,12 @@
         </p:nvSpPr>
         <p:spPr>
           <a:xfrm>
-            <a:off x="594360" y="2011680"/>
-            <a:ext cx="2084832" cy="2651760"/>
+            <a:off x="457200" y="2011680"/>
+            <a:ext cx="1874520" cy="2651760"/>
           </a:xfrm>
           <a:prstGeom prst="roundRect">
             <a:avLst>
-              <a:gd name="adj" fmla="val 4386"/>
+              <a:gd name="adj" fmla="val 4878"/>
             </a:avLst>
           </a:prstGeom>
           <a:solidFill>
@@ -11186,157 +11186,287 @@
         </p:nvSpPr>
         <p:spPr>
           <a:xfrm>
-            <a:off x="594360" y="2148840"/>
-            <a:ext cx="2084832" cy="868680"/>
-          </a:xfrm>
-          <a:prstGeom prst="rect">
-            <a:avLst/>
-          </a:prstGeom>
-          <a:noFill/>
-          <a:ln/>
-        </p:spPr>
-        <p:txBody>
-          <a:bodyPr wrap="square" rtlCol="0" anchor="ctr"/>
+            <a:off x="457200" y="2121408"/>
+            <a:ext cx="1874520" cy="457200"/>
+          </a:xfrm>
+          <a:prstGeom prst="rect">
+            <a:avLst/>
+          </a:prstGeom>
+          <a:noFill/>
+          <a:ln/>
+        </p:spPr>
+        <p:txBody>
+          <a:bodyPr wrap="square" lIns="0" tIns="0" rIns="0" bIns="0" rtlCol="0" anchor="ctr"/>
           <a:lstStyle/>
           <a:p>
             <a:pPr algn="ctr" indent="0" marL="0">
-              <a:buNone/>
-            </a:pPr>
-            <a:r>
-              <a:rPr lang="en-US" sz="1400" b="1" dirty="0">
+              <a:lnSpc>
+                <a:spcPct val="100000"/>
+              </a:lnSpc>
+              <a:buNone/>
+            </a:pPr>
+            <a:r>
+              <a:rPr lang="en-US" sz="1250" b="1" dirty="0">
+                <a:solidFill>
+                  <a:srgbClr val="B85042"/>
+                </a:solidFill>
+              </a:rPr>
+              <a:t>1</a:t>
+            </a:r>
+            <a:pPr algn="ctr" indent="0" marL="0">
+              <a:lnSpc>
+                <a:spcPct val="100000"/>
+              </a:lnSpc>
+              <a:buNone/>
+            </a:pPr>
+            <a:r>
+              <a:rPr lang="en-US" sz="1250" b="1" dirty="0">
                 <a:solidFill>
                   <a:srgbClr val="1E2761"/>
                 </a:solidFill>
               </a:rPr>
-              <a:t>Raw audit logs</a:t>
-            </a:r>
-            <a:endParaRPr lang="en-US" sz="1400" dirty="0"/>
-          </a:p>
-        </p:txBody>
-      </p:sp>
-      <p:sp>
-        <p:nvSpPr>
-          <p:cNvPr id="5" name="Text 3"/>
-          <p:cNvSpPr/>
-          <p:nvPr/>
-        </p:nvSpPr>
-        <p:spPr>
-          <a:xfrm>
-            <a:off x="667512" y="3063240"/>
-            <a:ext cx="1938528" cy="1463040"/>
-          </a:xfrm>
-          <a:prstGeom prst="rect">
-            <a:avLst/>
-          </a:prstGeom>
-          <a:noFill/>
-          <a:ln/>
-        </p:spPr>
-        <p:txBody>
-          <a:bodyPr wrap="square" rtlCol="0" anchor="ctr"/>
-          <a:lstStyle/>
-          <a:p>
-            <a:pPr algn="ctr" indent="0" marL="0">
-              <a:lnSpc>
-                <a:spcPct val="115000"/>
-              </a:lnSpc>
-              <a:buNone/>
-            </a:pPr>
-            <a:r>
-              <a:rPr lang="en-US" sz="1050" dirty="0">
-                <a:solidFill>
-                  <a:srgbClr val="5A6270"/>
-                </a:solidFill>
-              </a:rPr>
-              <a:t>SurveyCTO CSV (epoch ms)</a:t>
-            </a:r>
-            <a:endParaRPr lang="en-US" sz="1050" dirty="0"/>
-          </a:p>
-          <a:p>
-            <a:pPr algn="ctr" indent="0" marL="0">
-              <a:lnSpc>
-                <a:spcPct val="115000"/>
-              </a:lnSpc>
-              <a:buNone/>
-            </a:pPr>
-            <a:r>
-              <a:rPr lang="en-US" sz="1050" dirty="0">
-                <a:solidFill>
-                  <a:srgbClr val="5A6270"/>
-                </a:solidFill>
-              </a:rPr>
-              <a:t>ODK CSV (ISO 8601)</a:t>
-            </a:r>
-            <a:endParaRPr lang="en-US" sz="1050" dirty="0"/>
-          </a:p>
-          <a:p>
-            <a:pPr algn="ctr" indent="0" marL="0">
-              <a:lnSpc>
-                <a:spcPct val="115000"/>
-              </a:lnSpc>
-              <a:buNone/>
-            </a:pPr>
-            <a:r>
-              <a:rPr lang="en-US" sz="1050" dirty="0">
-                <a:solidFill>
-                  <a:srgbClr val="5A6270"/>
-                </a:solidFill>
-              </a:rPr>
-              <a:t>hybrid merged files</a:t>
-            </a:r>
-            <a:endParaRPr lang="en-US" sz="1050" dirty="0"/>
-          </a:p>
-        </p:txBody>
-      </p:sp>
-      <p:sp>
-        <p:nvSpPr>
-          <p:cNvPr id="6" name="Text 4"/>
-          <p:cNvSpPr/>
-          <p:nvPr/>
-        </p:nvSpPr>
-        <p:spPr>
-          <a:xfrm>
-            <a:off x="2624328" y="3063240"/>
-            <a:ext cx="329184" cy="548640"/>
-          </a:xfrm>
-          <a:prstGeom prst="rect">
-            <a:avLst/>
-          </a:prstGeom>
-          <a:noFill/>
-          <a:ln/>
-        </p:spPr>
-        <p:txBody>
-          <a:bodyPr wrap="square" lIns="0" tIns="0" rIns="0" bIns="0" rtlCol="0" anchor="ctr"/>
-          <a:lstStyle/>
-          <a:p>
-            <a:pPr algn="ctr" indent="0" marL="0">
-              <a:buNone/>
-            </a:pPr>
-            <a:r>
-              <a:rPr lang="en-US" sz="2200" b="1" dirty="0">
-                <a:solidFill>
-                  <a:srgbClr val="B85042"/>
-                </a:solidFill>
-              </a:rPr>
-              <a:t>→</a:t>
-            </a:r>
-            <a:endParaRPr lang="en-US" sz="2200" dirty="0"/>
-          </a:p>
-        </p:txBody>
-      </p:sp>
-      <p:sp>
-        <p:nvSpPr>
-          <p:cNvPr id="7" name="Shape 5"/>
-          <p:cNvSpPr/>
-          <p:nvPr/>
-        </p:nvSpPr>
-        <p:spPr>
-          <a:xfrm>
-            <a:off x="2880360" y="2011680"/>
-            <a:ext cx="2084832" cy="2651760"/>
+              <a:t>  Raw audit logs</a:t>
+            </a:r>
+            <a:endParaRPr lang="en-US" sz="1250" dirty="0"/>
+          </a:p>
+        </p:txBody>
+      </p:sp>
+      <p:sp>
+        <p:nvSpPr>
+          <p:cNvPr id="5" name="Shape 3"/>
+          <p:cNvSpPr/>
+          <p:nvPr/>
+        </p:nvSpPr>
+        <p:spPr>
+          <a:xfrm>
+            <a:off x="603504" y="2606040"/>
+            <a:ext cx="1581912" cy="658368"/>
           </a:xfrm>
           <a:prstGeom prst="roundRect">
             <a:avLst>
-              <a:gd name="adj" fmla="val 4386"/>
+              <a:gd name="adj" fmla="val 6944"/>
+            </a:avLst>
+          </a:prstGeom>
+          <a:solidFill>
+            <a:srgbClr val="FFFFFF"/>
+          </a:solidFill>
+          <a:ln w="9525">
+            <a:solidFill>
+              <a:srgbClr val="C2CCE0"/>
+            </a:solidFill>
+            <a:prstDash val="solid"/>
+          </a:ln>
+        </p:spPr>
+      </p:sp>
+      <p:sp>
+        <p:nvSpPr>
+          <p:cNvPr id="6" name="Text 4"/>
+          <p:cNvSpPr/>
+          <p:nvPr/>
+        </p:nvSpPr>
+        <p:spPr>
+          <a:xfrm>
+            <a:off x="603504" y="2606040"/>
+            <a:ext cx="1581912" cy="658368"/>
+          </a:xfrm>
+          <a:prstGeom prst="rect">
+            <a:avLst/>
+          </a:prstGeom>
+          <a:noFill/>
+          <a:ln/>
+        </p:spPr>
+        <p:txBody>
+          <a:bodyPr wrap="square" lIns="0" tIns="0" rIns="0" bIns="0" rtlCol="0" anchor="ctr"/>
+          <a:lstStyle/>
+          <a:p>
+            <a:pPr algn="ctr" indent="0" marL="0">
+              <a:lnSpc>
+                <a:spcPct val="100000"/>
+              </a:lnSpc>
+              <a:buNone/>
+            </a:pPr>
+            <a:r>
+              <a:rPr lang="en-US" sz="1050" b="1" dirty="0">
+                <a:solidFill>
+                  <a:srgbClr val="1E2761"/>
+                </a:solidFill>
+              </a:rPr>
+              <a:t>SurveyCTO CSV</a:t>
+            </a:r>
+            <a:endParaRPr lang="en-US" sz="1050" dirty="0"/>
+          </a:p>
+          <a:p>
+            <a:pPr algn="ctr" indent="0" marL="0">
+              <a:lnSpc>
+                <a:spcPct val="100000"/>
+              </a:lnSpc>
+              <a:buNone/>
+            </a:pPr>
+            <a:r>
+              <a:rPr lang="en-US" sz="900" dirty="0">
+                <a:solidFill>
+                  <a:srgbClr val="5A6270"/>
+                </a:solidFill>
+              </a:rPr>
+              <a:t>epoch ms</a:t>
+            </a:r>
+            <a:endParaRPr lang="en-US" sz="1050" dirty="0"/>
+          </a:p>
+        </p:txBody>
+      </p:sp>
+      <p:sp>
+        <p:nvSpPr>
+          <p:cNvPr id="7" name="Shape 5"/>
+          <p:cNvSpPr/>
+          <p:nvPr/>
+        </p:nvSpPr>
+        <p:spPr>
+          <a:xfrm>
+            <a:off x="603504" y="3355848"/>
+            <a:ext cx="1581912" cy="658368"/>
+          </a:xfrm>
+          <a:prstGeom prst="roundRect">
+            <a:avLst>
+              <a:gd name="adj" fmla="val 6944"/>
+            </a:avLst>
+          </a:prstGeom>
+          <a:solidFill>
+            <a:srgbClr val="FFFFFF"/>
+          </a:solidFill>
+          <a:ln w="9525">
+            <a:solidFill>
+              <a:srgbClr val="C2CCE0"/>
+            </a:solidFill>
+            <a:prstDash val="solid"/>
+          </a:ln>
+        </p:spPr>
+      </p:sp>
+      <p:sp>
+        <p:nvSpPr>
+          <p:cNvPr id="8" name="Text 6"/>
+          <p:cNvSpPr/>
+          <p:nvPr/>
+        </p:nvSpPr>
+        <p:spPr>
+          <a:xfrm>
+            <a:off x="603504" y="3355848"/>
+            <a:ext cx="1581912" cy="658368"/>
+          </a:xfrm>
+          <a:prstGeom prst="rect">
+            <a:avLst/>
+          </a:prstGeom>
+          <a:noFill/>
+          <a:ln/>
+        </p:spPr>
+        <p:txBody>
+          <a:bodyPr wrap="square" lIns="0" tIns="0" rIns="0" bIns="0" rtlCol="0" anchor="ctr"/>
+          <a:lstStyle/>
+          <a:p>
+            <a:pPr algn="ctr" indent="0" marL="0">
+              <a:lnSpc>
+                <a:spcPct val="100000"/>
+              </a:lnSpc>
+              <a:buNone/>
+            </a:pPr>
+            <a:r>
+              <a:rPr lang="en-US" sz="1050" b="1" dirty="0">
+                <a:solidFill>
+                  <a:srgbClr val="1E2761"/>
+                </a:solidFill>
+              </a:rPr>
+              <a:t>ODK CSV</a:t>
+            </a:r>
+            <a:endParaRPr lang="en-US" sz="1050" dirty="0"/>
+          </a:p>
+          <a:p>
+            <a:pPr algn="ctr" indent="0" marL="0">
+              <a:lnSpc>
+                <a:spcPct val="100000"/>
+              </a:lnSpc>
+              <a:buNone/>
+            </a:pPr>
+            <a:r>
+              <a:rPr lang="en-US" sz="900" dirty="0">
+                <a:solidFill>
+                  <a:srgbClr val="5A6270"/>
+                </a:solidFill>
+              </a:rPr>
+              <a:t>ISO 8601</a:t>
+            </a:r>
+            <a:endParaRPr lang="en-US" sz="1050" dirty="0"/>
+          </a:p>
+        </p:txBody>
+      </p:sp>
+      <p:sp>
+        <p:nvSpPr>
+          <p:cNvPr id="9" name="Text 7"/>
+          <p:cNvSpPr/>
+          <p:nvPr/>
+        </p:nvSpPr>
+        <p:spPr>
+          <a:xfrm>
+            <a:off x="475488" y="4096512"/>
+            <a:ext cx="1837944" cy="502920"/>
+          </a:xfrm>
+          <a:prstGeom prst="rect">
+            <a:avLst/>
+          </a:prstGeom>
+          <a:noFill/>
+          <a:ln/>
+        </p:spPr>
+        <p:txBody>
+          <a:bodyPr wrap="square" rtlCol="0" anchor="ctr"/>
+          <a:lstStyle/>
+          <a:p>
+            <a:pPr algn="ctr" indent="0" marL="0">
+              <a:lnSpc>
+                <a:spcPct val="100000"/>
+              </a:lnSpc>
+              <a:buNone/>
+            </a:pPr>
+            <a:r>
+              <a:rPr lang="en-US" sz="900" i="1" dirty="0">
+                <a:solidFill>
+                  <a:srgbClr val="5A6270"/>
+                </a:solidFill>
+              </a:rPr>
+              <a:t>hybrid merged files</a:t>
+            </a:r>
+            <a:endParaRPr lang="en-US" sz="900" dirty="0"/>
+          </a:p>
+          <a:p>
+            <a:pPr algn="ctr" indent="0" marL="0">
+              <a:lnSpc>
+                <a:spcPct val="100000"/>
+              </a:lnSpc>
+              <a:buNone/>
+            </a:pPr>
+            <a:r>
+              <a:rPr lang="en-US" sz="900" i="1" dirty="0">
+                <a:solidFill>
+                  <a:srgbClr val="5A6270"/>
+                </a:solidFill>
+              </a:rPr>
+              <a:t>auto-detected</a:t>
+            </a:r>
+            <a:endParaRPr lang="en-US" sz="900" dirty="0"/>
+          </a:p>
+        </p:txBody>
+      </p:sp>
+      <p:sp>
+        <p:nvSpPr>
+          <p:cNvPr id="10" name="Shape 8"/>
+          <p:cNvSpPr/>
+          <p:nvPr/>
+        </p:nvSpPr>
+        <p:spPr>
+          <a:xfrm>
+            <a:off x="2697480" y="2011680"/>
+            <a:ext cx="1874520" cy="2651760"/>
+          </a:xfrm>
+          <a:prstGeom prst="roundRect">
+            <a:avLst>
+              <a:gd name="adj" fmla="val 4878"/>
             </a:avLst>
           </a:prstGeom>
           <a:solidFill>
@@ -11347,163 +11477,277 @@
       </p:sp>
       <p:sp>
         <p:nvSpPr>
-          <p:cNvPr id="8" name="Text 6"/>
-          <p:cNvSpPr/>
-          <p:nvPr/>
-        </p:nvSpPr>
-        <p:spPr>
-          <a:xfrm>
-            <a:off x="2880360" y="2148840"/>
-            <a:ext cx="2084832" cy="868680"/>
-          </a:xfrm>
-          <a:prstGeom prst="rect">
-            <a:avLst/>
-          </a:prstGeom>
-          <a:noFill/>
-          <a:ln/>
-        </p:spPr>
-        <p:txBody>
-          <a:bodyPr wrap="square" rtlCol="0" anchor="ctr"/>
+          <p:cNvPr id="11" name="Text 9"/>
+          <p:cNvSpPr/>
+          <p:nvPr/>
+        </p:nvSpPr>
+        <p:spPr>
+          <a:xfrm>
+            <a:off x="2697480" y="2121408"/>
+            <a:ext cx="1874520" cy="457200"/>
+          </a:xfrm>
+          <a:prstGeom prst="rect">
+            <a:avLst/>
+          </a:prstGeom>
+          <a:noFill/>
+          <a:ln/>
+        </p:spPr>
+        <p:txBody>
+          <a:bodyPr wrap="square" lIns="0" tIns="0" rIns="0" bIns="0" rtlCol="0" anchor="ctr"/>
           <a:lstStyle/>
           <a:p>
             <a:pPr algn="ctr" indent="0" marL="0">
-              <a:buNone/>
-            </a:pPr>
-            <a:r>
-              <a:rPr lang="en-US" sz="1400" b="1" dirty="0">
+              <a:lnSpc>
+                <a:spcPct val="100000"/>
+              </a:lnSpc>
+              <a:buNone/>
+            </a:pPr>
+            <a:r>
+              <a:rPr lang="en-US" sz="1250" b="1" dirty="0">
+                <a:solidFill>
+                  <a:srgbClr val="B85042"/>
+                </a:solidFill>
+              </a:rPr>
+              <a:t>2</a:t>
+            </a:r>
+            <a:pPr algn="ctr" indent="0" marL="0">
+              <a:lnSpc>
+                <a:spcPct val="100000"/>
+              </a:lnSpc>
+              <a:buNone/>
+            </a:pPr>
+            <a:r>
+              <a:rPr lang="en-US" sz="1250" b="1" dirty="0">
                 <a:solidFill>
                   <a:srgbClr val="1E2761"/>
                 </a:solidFill>
               </a:rPr>
-              <a:t>Parsers</a:t>
-            </a:r>
-            <a:endParaRPr lang="en-US" sz="1400" dirty="0"/>
-          </a:p>
-        </p:txBody>
-      </p:sp>
-      <p:sp>
-        <p:nvSpPr>
-          <p:cNvPr id="9" name="Text 7"/>
-          <p:cNvSpPr/>
-          <p:nvPr/>
-        </p:nvSpPr>
-        <p:spPr>
-          <a:xfrm>
-            <a:off x="2953512" y="3063240"/>
-            <a:ext cx="1938528" cy="1463040"/>
-          </a:xfrm>
-          <a:prstGeom prst="rect">
-            <a:avLst/>
-          </a:prstGeom>
-          <a:noFill/>
-          <a:ln/>
-        </p:spPr>
-        <p:txBody>
-          <a:bodyPr wrap="square" rtlCol="0" anchor="ctr"/>
-          <a:lstStyle/>
-          <a:p>
-            <a:pPr algn="ctr" indent="0" marL="0">
-              <a:lnSpc>
-                <a:spcPct val="115000"/>
-              </a:lnSpc>
-              <a:buNone/>
-            </a:pPr>
-            <a:r>
-              <a:rPr lang="en-US" sz="1050" dirty="0">
-                <a:solidFill>
-                  <a:srgbClr val="5A6270"/>
-                </a:solidFill>
-              </a:rPr>
-              <a:t>auto-detection</a:t>
-            </a:r>
-            <a:endParaRPr lang="en-US" sz="1050" dirty="0"/>
-          </a:p>
-          <a:p>
-            <a:pPr algn="ctr" indent="0" marL="0">
-              <a:lnSpc>
-                <a:spcPct val="115000"/>
-              </a:lnSpc>
-              <a:buNone/>
-            </a:pPr>
-            <a:r>
-              <a:rPr lang="en-US" sz="1050" dirty="0">
-                <a:solidFill>
-                  <a:srgbClr val="5A6270"/>
-                </a:solidFill>
-              </a:rPr>
-              <a:t>SurveyCTOParser</a:t>
-            </a:r>
-            <a:endParaRPr lang="en-US" sz="1050" dirty="0"/>
-          </a:p>
-          <a:p>
-            <a:pPr algn="ctr" indent="0" marL="0">
-              <a:lnSpc>
-                <a:spcPct val="115000"/>
-              </a:lnSpc>
-              <a:buNone/>
-            </a:pPr>
-            <a:r>
-              <a:rPr lang="en-US" sz="1050" dirty="0">
-                <a:solidFill>
-                  <a:srgbClr val="5A6270"/>
-                </a:solidFill>
-              </a:rPr>
-              <a:t>ODKParser</a:t>
-            </a:r>
-            <a:endParaRPr lang="en-US" sz="1050" dirty="0"/>
-          </a:p>
-        </p:txBody>
-      </p:sp>
-      <p:sp>
-        <p:nvSpPr>
-          <p:cNvPr id="10" name="Text 8"/>
-          <p:cNvSpPr/>
-          <p:nvPr/>
-        </p:nvSpPr>
-        <p:spPr>
-          <a:xfrm>
-            <a:off x="4910328" y="3063240"/>
-            <a:ext cx="329184" cy="548640"/>
-          </a:xfrm>
-          <a:prstGeom prst="rect">
-            <a:avLst/>
-          </a:prstGeom>
-          <a:noFill/>
-          <a:ln/>
-        </p:spPr>
-        <p:txBody>
-          <a:bodyPr wrap="square" lIns="0" tIns="0" rIns="0" bIns="0" rtlCol="0" anchor="ctr"/>
-          <a:lstStyle/>
-          <a:p>
-            <a:pPr algn="ctr" indent="0" marL="0">
-              <a:buNone/>
-            </a:pPr>
-            <a:r>
-              <a:rPr lang="en-US" sz="2200" b="1" dirty="0">
-                <a:solidFill>
-                  <a:srgbClr val="B85042"/>
-                </a:solidFill>
-              </a:rPr>
-              <a:t>→</a:t>
-            </a:r>
-            <a:endParaRPr lang="en-US" sz="2200" dirty="0"/>
-          </a:p>
-        </p:txBody>
-      </p:sp>
-      <p:sp>
-        <p:nvSpPr>
-          <p:cNvPr id="11" name="Shape 9"/>
-          <p:cNvSpPr/>
-          <p:nvPr/>
-        </p:nvSpPr>
-        <p:spPr>
-          <a:xfrm>
-            <a:off x="5166360" y="2011680"/>
-            <a:ext cx="2084832" cy="2651760"/>
+              <a:t>  Parsers</a:t>
+            </a:r>
+            <a:endParaRPr lang="en-US" sz="1250" dirty="0"/>
+          </a:p>
+        </p:txBody>
+      </p:sp>
+      <p:sp>
+        <p:nvSpPr>
+          <p:cNvPr id="12" name="Shape 10"/>
+          <p:cNvSpPr/>
+          <p:nvPr/>
+        </p:nvSpPr>
+        <p:spPr>
+          <a:xfrm>
+            <a:off x="2843784" y="2606040"/>
+            <a:ext cx="1581912" cy="658368"/>
           </a:xfrm>
           <a:prstGeom prst="roundRect">
             <a:avLst>
-              <a:gd name="adj" fmla="val 4386"/>
+              <a:gd name="adj" fmla="val 6944"/>
+            </a:avLst>
+          </a:prstGeom>
+          <a:solidFill>
+            <a:srgbClr val="FFFFFF"/>
+          </a:solidFill>
+          <a:ln w="9525">
+            <a:solidFill>
+              <a:srgbClr val="C2CCE0"/>
+            </a:solidFill>
+            <a:prstDash val="solid"/>
+          </a:ln>
+        </p:spPr>
+      </p:sp>
+      <p:sp>
+        <p:nvSpPr>
+          <p:cNvPr id="13" name="Text 11"/>
+          <p:cNvSpPr/>
+          <p:nvPr/>
+        </p:nvSpPr>
+        <p:spPr>
+          <a:xfrm>
+            <a:off x="2843784" y="2606040"/>
+            <a:ext cx="1581912" cy="658368"/>
+          </a:xfrm>
+          <a:prstGeom prst="rect">
+            <a:avLst/>
+          </a:prstGeom>
+          <a:noFill/>
+          <a:ln/>
+        </p:spPr>
+        <p:txBody>
+          <a:bodyPr wrap="square" lIns="0" tIns="0" rIns="0" bIns="0" rtlCol="0" anchor="ctr"/>
+          <a:lstStyle/>
+          <a:p>
+            <a:pPr algn="ctr" indent="0" marL="0">
+              <a:lnSpc>
+                <a:spcPct val="100000"/>
+              </a:lnSpc>
+              <a:buNone/>
+            </a:pPr>
+            <a:r>
+              <a:rPr lang="en-US" sz="1050" b="1" dirty="0">
+                <a:solidFill>
+                  <a:srgbClr val="1E2761"/>
+                </a:solidFill>
+              </a:rPr>
+              <a:t>SurveyCTOParser</a:t>
+            </a:r>
+            <a:endParaRPr lang="en-US" sz="1050" dirty="0"/>
+          </a:p>
+          <a:p>
+            <a:pPr algn="ctr" indent="0" marL="0">
+              <a:lnSpc>
+                <a:spcPct val="100000"/>
+              </a:lnSpc>
+              <a:buNone/>
+            </a:pPr>
+            <a:endParaRPr lang="en-US" sz="1050" dirty="0"/>
+          </a:p>
+        </p:txBody>
+      </p:sp>
+      <p:sp>
+        <p:nvSpPr>
+          <p:cNvPr id="14" name="Shape 12"/>
+          <p:cNvSpPr/>
+          <p:nvPr/>
+        </p:nvSpPr>
+        <p:spPr>
+          <a:xfrm>
+            <a:off x="2843784" y="3355848"/>
+            <a:ext cx="1581912" cy="658368"/>
+          </a:xfrm>
+          <a:prstGeom prst="roundRect">
+            <a:avLst>
+              <a:gd name="adj" fmla="val 6944"/>
+            </a:avLst>
+          </a:prstGeom>
+          <a:solidFill>
+            <a:srgbClr val="FFFFFF"/>
+          </a:solidFill>
+          <a:ln w="9525">
+            <a:solidFill>
+              <a:srgbClr val="C2CCE0"/>
+            </a:solidFill>
+            <a:prstDash val="solid"/>
+          </a:ln>
+        </p:spPr>
+      </p:sp>
+      <p:sp>
+        <p:nvSpPr>
+          <p:cNvPr id="15" name="Text 13"/>
+          <p:cNvSpPr/>
+          <p:nvPr/>
+        </p:nvSpPr>
+        <p:spPr>
+          <a:xfrm>
+            <a:off x="2843784" y="3355848"/>
+            <a:ext cx="1581912" cy="658368"/>
+          </a:xfrm>
+          <a:prstGeom prst="rect">
+            <a:avLst/>
+          </a:prstGeom>
+          <a:noFill/>
+          <a:ln/>
+        </p:spPr>
+        <p:txBody>
+          <a:bodyPr wrap="square" lIns="0" tIns="0" rIns="0" bIns="0" rtlCol="0" anchor="ctr"/>
+          <a:lstStyle/>
+          <a:p>
+            <a:pPr algn="ctr" indent="0" marL="0">
+              <a:lnSpc>
+                <a:spcPct val="100000"/>
+              </a:lnSpc>
+              <a:buNone/>
+            </a:pPr>
+            <a:r>
+              <a:rPr lang="en-US" sz="1050" b="1" dirty="0">
+                <a:solidFill>
+                  <a:srgbClr val="1E2761"/>
+                </a:solidFill>
+              </a:rPr>
+              <a:t>ODKParser</a:t>
+            </a:r>
+            <a:endParaRPr lang="en-US" sz="1050" dirty="0"/>
+          </a:p>
+          <a:p>
+            <a:pPr algn="ctr" indent="0" marL="0">
+              <a:lnSpc>
+                <a:spcPct val="100000"/>
+              </a:lnSpc>
+              <a:buNone/>
+            </a:pPr>
+            <a:endParaRPr lang="en-US" sz="1050" dirty="0"/>
+          </a:p>
+        </p:txBody>
+      </p:sp>
+      <p:sp>
+        <p:nvSpPr>
+          <p:cNvPr id="16" name="Text 14"/>
+          <p:cNvSpPr/>
+          <p:nvPr/>
+        </p:nvSpPr>
+        <p:spPr>
+          <a:xfrm>
+            <a:off x="2715768" y="4096512"/>
+            <a:ext cx="1837944" cy="502920"/>
+          </a:xfrm>
+          <a:prstGeom prst="rect">
+            <a:avLst/>
+          </a:prstGeom>
+          <a:noFill/>
+          <a:ln/>
+        </p:spPr>
+        <p:txBody>
+          <a:bodyPr wrap="square" rtlCol="0" anchor="ctr"/>
+          <a:lstStyle/>
+          <a:p>
+            <a:pPr algn="ctr" indent="0" marL="0">
+              <a:lnSpc>
+                <a:spcPct val="100000"/>
+              </a:lnSpc>
+              <a:buNone/>
+            </a:pPr>
+            <a:r>
+              <a:rPr lang="en-US" sz="900" i="1" dirty="0">
+                <a:solidFill>
+                  <a:srgbClr val="5A6270"/>
+                </a:solidFill>
+              </a:rPr>
+              <a:t>normalise events</a:t>
+            </a:r>
+            <a:endParaRPr lang="en-US" sz="900" dirty="0"/>
+          </a:p>
+          <a:p>
+            <a:pPr algn="ctr" indent="0" marL="0">
+              <a:lnSpc>
+                <a:spcPct val="100000"/>
+              </a:lnSpc>
+              <a:buNone/>
+            </a:pPr>
+            <a:r>
+              <a:rPr lang="en-US" sz="900" i="1" dirty="0">
+                <a:solidFill>
+                  <a:srgbClr val="5A6270"/>
+                </a:solidFill>
+              </a:rPr>
+              <a:t>&amp; timestamps</a:t>
+            </a:r>
+            <a:endParaRPr lang="en-US" sz="900" dirty="0"/>
+          </a:p>
+        </p:txBody>
+      </p:sp>
+      <p:sp>
+        <p:nvSpPr>
+          <p:cNvPr id="17" name="Shape 15"/>
+          <p:cNvSpPr/>
+          <p:nvPr/>
+        </p:nvSpPr>
+        <p:spPr>
+          <a:xfrm>
+            <a:off x="4937760" y="1737360"/>
+            <a:ext cx="2468880" cy="3154680"/>
+          </a:xfrm>
+          <a:prstGeom prst="roundRect">
+            <a:avLst>
+              <a:gd name="adj" fmla="val 3704"/>
             </a:avLst>
           </a:prstGeom>
           <a:solidFill>
@@ -11514,14 +11758,14 @@
       </p:sp>
       <p:sp>
         <p:nvSpPr>
-          <p:cNvPr id="12" name="Text 10"/>
-          <p:cNvSpPr/>
-          <p:nvPr/>
-        </p:nvSpPr>
-        <p:spPr>
-          <a:xfrm>
-            <a:off x="5166360" y="2148840"/>
-            <a:ext cx="2084832" cy="868680"/>
+          <p:cNvPr id="18" name="Text 16"/>
+          <p:cNvSpPr/>
+          <p:nvPr/>
+        </p:nvSpPr>
+        <p:spPr>
+          <a:xfrm>
+            <a:off x="5120640" y="1901952"/>
+            <a:ext cx="2103120" cy="822960"/>
           </a:xfrm>
           <a:prstGeom prst="rect">
             <a:avLst/>
@@ -11534,44 +11778,83 @@
           <a:lstStyle/>
           <a:p>
             <a:pPr algn="ctr" indent="0" marL="0">
-              <a:buNone/>
-            </a:pPr>
-            <a:r>
-              <a:rPr lang="en-US" sz="1400" b="1" dirty="0">
+              <a:lnSpc>
+                <a:spcPct val="100000"/>
+              </a:lnSpc>
+              <a:buNone/>
+            </a:pPr>
+            <a:r>
+              <a:rPr lang="en-US" sz="1250" b="1" dirty="0">
+                <a:solidFill>
+                  <a:srgbClr val="CADCFC"/>
+                </a:solidFill>
+              </a:rPr>
+              <a:t>3</a:t>
+            </a:r>
+            <a:pPr algn="ctr" indent="0" marL="0">
+              <a:lnSpc>
+                <a:spcPct val="100000"/>
+              </a:lnSpc>
+              <a:buNone/>
+            </a:pPr>
+            <a:r>
+              <a:rPr lang="en-US" sz="1250" b="1" dirty="0">
                 <a:solidFill>
                   <a:srgbClr val="FFFFFF"/>
                 </a:solidFill>
               </a:rPr>
-              <a:t>Common intermediate</a:t>
-            </a:r>
-            <a:endParaRPr lang="en-US" sz="1400" dirty="0"/>
-          </a:p>
+              <a:t>  Common intermediate representation</a:t>
+            </a:r>
+            <a:endParaRPr lang="en-US" sz="1250" dirty="0"/>
+          </a:p>
+        </p:txBody>
+      </p:sp>
+      <p:sp>
+        <p:nvSpPr>
+          <p:cNvPr id="19" name="Text 17"/>
+          <p:cNvSpPr/>
+          <p:nvPr/>
+        </p:nvSpPr>
+        <p:spPr>
+          <a:xfrm>
+            <a:off x="5120640" y="2724912"/>
+            <a:ext cx="2103120" cy="320040"/>
+          </a:xfrm>
+          <a:prstGeom prst="rect">
+            <a:avLst/>
+          </a:prstGeom>
+          <a:noFill/>
+          <a:ln/>
+        </p:spPr>
+        <p:txBody>
+          <a:bodyPr wrap="square" rtlCol="0" anchor="ctr"/>
+          <a:lstStyle/>
           <a:p>
             <a:pPr algn="ctr" indent="0" marL="0">
               <a:buNone/>
             </a:pPr>
             <a:r>
-              <a:rPr lang="en-US" sz="1400" b="1" dirty="0">
-                <a:solidFill>
-                  <a:srgbClr val="FFFFFF"/>
-                </a:solidFill>
-              </a:rPr>
-              <a:t>representation</a:t>
-            </a:r>
-            <a:endParaRPr lang="en-US" sz="1400" dirty="0"/>
-          </a:p>
-        </p:txBody>
-      </p:sp>
-      <p:sp>
-        <p:nvSpPr>
-          <p:cNvPr id="13" name="Text 11"/>
-          <p:cNvSpPr/>
-          <p:nvPr/>
-        </p:nvSpPr>
-        <p:spPr>
-          <a:xfrm>
-            <a:off x="5239512" y="3063240"/>
-            <a:ext cx="1938528" cy="1463040"/>
+              <a:rPr lang="en-US" sz="950" i="1" dirty="0">
+                <a:solidFill>
+                  <a:srgbClr val="CADCFC"/>
+                </a:solidFill>
+              </a:rPr>
+              <a:t>one table, every stage below depends on it</a:t>
+            </a:r>
+            <a:endParaRPr lang="en-US" sz="950" dirty="0"/>
+          </a:p>
+        </p:txBody>
+      </p:sp>
+      <p:sp>
+        <p:nvSpPr>
+          <p:cNvPr id="20" name="Text 18"/>
+          <p:cNvSpPr/>
+          <p:nvPr/>
+        </p:nvSpPr>
+        <p:spPr>
+          <a:xfrm>
+            <a:off x="5257800" y="3090672"/>
+            <a:ext cx="1828800" cy="1691640"/>
           </a:xfrm>
           <a:prstGeom prst="rect">
             <a:avLst/>
@@ -11585,106 +11868,139 @@
           <a:p>
             <a:pPr algn="ctr" indent="0" marL="0">
               <a:lnSpc>
-                <a:spcPct val="115000"/>
-              </a:lnSpc>
-              <a:buNone/>
-            </a:pPr>
-            <a:r>
-              <a:rPr lang="en-US" sz="1050" dirty="0">
+                <a:spcPct val="112000"/>
+              </a:lnSpc>
+              <a:buNone/>
+            </a:pPr>
+            <a:r>
+              <a:rPr lang="en-US" sz="1150" dirty="0">
                 <a:solidFill>
                   <a:srgbClr val="CADCFC"/>
                 </a:solidFill>
-              </a:rPr>
-              <a:t>interview_id, field_name,</a:t>
-            </a:r>
-            <a:endParaRPr lang="en-US" sz="1050" dirty="0"/>
+                <a:latin typeface="Courier New" pitchFamily="34" charset="0"/>
+                <a:ea typeface="Courier New" pitchFamily="34" charset="-122"/>
+                <a:cs typeface="Courier New" pitchFamily="34" charset="-120"/>
+              </a:rPr>
+              <a:t>interview_id</a:t>
+            </a:r>
+            <a:endParaRPr lang="en-US" sz="1150" dirty="0"/>
           </a:p>
           <a:p>
             <a:pPr algn="ctr" indent="0" marL="0">
               <a:lnSpc>
-                <a:spcPct val="115000"/>
-              </a:lnSpc>
-              <a:buNone/>
-            </a:pPr>
-            <a:r>
-              <a:rPr lang="en-US" sz="1050" dirty="0">
+                <a:spcPct val="112000"/>
+              </a:lnSpc>
+              <a:buNone/>
+            </a:pPr>
+            <a:r>
+              <a:rPr lang="en-US" sz="1150" dirty="0">
                 <a:solidFill>
                   <a:srgbClr val="CADCFC"/>
                 </a:solidFill>
-              </a:rPr>
-              <a:t>event_type, start_ms,</a:t>
-            </a:r>
-            <a:endParaRPr lang="en-US" sz="1050" dirty="0"/>
+                <a:latin typeface="Courier New" pitchFamily="34" charset="0"/>
+                <a:ea typeface="Courier New" pitchFamily="34" charset="-122"/>
+                <a:cs typeface="Courier New" pitchFamily="34" charset="-120"/>
+              </a:rPr>
+              <a:t>field_name</a:t>
+            </a:r>
+            <a:endParaRPr lang="en-US" sz="1150" dirty="0"/>
           </a:p>
           <a:p>
             <a:pPr algn="ctr" indent="0" marL="0">
               <a:lnSpc>
-                <a:spcPct val="115000"/>
-              </a:lnSpc>
-              <a:buNone/>
-            </a:pPr>
-            <a:r>
-              <a:rPr lang="en-US" sz="1050" dirty="0">
+                <a:spcPct val="112000"/>
+              </a:lnSpc>
+              <a:buNone/>
+            </a:pPr>
+            <a:r>
+              <a:rPr lang="en-US" sz="1150" dirty="0">
                 <a:solidFill>
                   <a:srgbClr val="CADCFC"/>
                 </a:solidFill>
-              </a:rPr>
-              <a:t>end_ms, duration_ms</a:t>
-            </a:r>
-            <a:endParaRPr lang="en-US" sz="1050" dirty="0"/>
-          </a:p>
-        </p:txBody>
-      </p:sp>
-      <p:sp>
-        <p:nvSpPr>
-          <p:cNvPr id="14" name="Text 12"/>
-          <p:cNvSpPr/>
-          <p:nvPr/>
-        </p:nvSpPr>
-        <p:spPr>
-          <a:xfrm>
-            <a:off x="7196328" y="3063240"/>
-            <a:ext cx="329184" cy="548640"/>
-          </a:xfrm>
-          <a:prstGeom prst="rect">
-            <a:avLst/>
-          </a:prstGeom>
-          <a:noFill/>
-          <a:ln/>
-        </p:spPr>
-        <p:txBody>
-          <a:bodyPr wrap="square" lIns="0" tIns="0" rIns="0" bIns="0" rtlCol="0" anchor="ctr"/>
-          <a:lstStyle/>
+                <a:latin typeface="Courier New" pitchFamily="34" charset="0"/>
+                <a:ea typeface="Courier New" pitchFamily="34" charset="-122"/>
+                <a:cs typeface="Courier New" pitchFamily="34" charset="-120"/>
+              </a:rPr>
+              <a:t>event_type</a:t>
+            </a:r>
+            <a:endParaRPr lang="en-US" sz="1150" dirty="0"/>
+          </a:p>
           <a:p>
             <a:pPr algn="ctr" indent="0" marL="0">
-              <a:buNone/>
-            </a:pPr>
-            <a:r>
-              <a:rPr lang="en-US" sz="2200" b="1" dirty="0">
-                <a:solidFill>
-                  <a:srgbClr val="B85042"/>
-                </a:solidFill>
-              </a:rPr>
-              <a:t>→</a:t>
-            </a:r>
-            <a:endParaRPr lang="en-US" sz="2200" dirty="0"/>
-          </a:p>
-        </p:txBody>
-      </p:sp>
-      <p:sp>
-        <p:nvSpPr>
-          <p:cNvPr id="15" name="Shape 13"/>
-          <p:cNvSpPr/>
-          <p:nvPr/>
-        </p:nvSpPr>
-        <p:spPr>
-          <a:xfrm>
-            <a:off x="7452360" y="2011680"/>
-            <a:ext cx="2084832" cy="2651760"/>
+              <a:lnSpc>
+                <a:spcPct val="112000"/>
+              </a:lnSpc>
+              <a:buNone/>
+            </a:pPr>
+            <a:r>
+              <a:rPr lang="en-US" sz="1150" dirty="0">
+                <a:solidFill>
+                  <a:srgbClr val="CADCFC"/>
+                </a:solidFill>
+                <a:latin typeface="Courier New" pitchFamily="34" charset="0"/>
+                <a:ea typeface="Courier New" pitchFamily="34" charset="-122"/>
+                <a:cs typeface="Courier New" pitchFamily="34" charset="-120"/>
+              </a:rPr>
+              <a:t>start_ms</a:t>
+            </a:r>
+            <a:endParaRPr lang="en-US" sz="1150" dirty="0"/>
+          </a:p>
+          <a:p>
+            <a:pPr algn="ctr" indent="0" marL="0">
+              <a:lnSpc>
+                <a:spcPct val="112000"/>
+              </a:lnSpc>
+              <a:buNone/>
+            </a:pPr>
+            <a:r>
+              <a:rPr lang="en-US" sz="1150" dirty="0">
+                <a:solidFill>
+                  <a:srgbClr val="CADCFC"/>
+                </a:solidFill>
+                <a:latin typeface="Courier New" pitchFamily="34" charset="0"/>
+                <a:ea typeface="Courier New" pitchFamily="34" charset="-122"/>
+                <a:cs typeface="Courier New" pitchFamily="34" charset="-120"/>
+              </a:rPr>
+              <a:t>end_ms</a:t>
+            </a:r>
+            <a:endParaRPr lang="en-US" sz="1150" dirty="0"/>
+          </a:p>
+          <a:p>
+            <a:pPr algn="ctr" indent="0" marL="0">
+              <a:lnSpc>
+                <a:spcPct val="112000"/>
+              </a:lnSpc>
+              <a:buNone/>
+            </a:pPr>
+            <a:r>
+              <a:rPr lang="en-US" sz="1150" dirty="0">
+                <a:solidFill>
+                  <a:srgbClr val="CADCFC"/>
+                </a:solidFill>
+                <a:latin typeface="Courier New" pitchFamily="34" charset="0"/>
+                <a:ea typeface="Courier New" pitchFamily="34" charset="-122"/>
+                <a:cs typeface="Courier New" pitchFamily="34" charset="-120"/>
+              </a:rPr>
+              <a:t>duration_ms</a:t>
+            </a:r>
+            <a:endParaRPr lang="en-US" sz="1150" dirty="0"/>
+          </a:p>
+        </p:txBody>
+      </p:sp>
+      <p:sp>
+        <p:nvSpPr>
+          <p:cNvPr id="21" name="Shape 19"/>
+          <p:cNvSpPr/>
+          <p:nvPr/>
+        </p:nvSpPr>
+        <p:spPr>
+          <a:xfrm>
+            <a:off x="7772400" y="2011680"/>
+            <a:ext cx="1783080" cy="2651760"/>
           </a:xfrm>
           <a:prstGeom prst="roundRect">
             <a:avLst>
-              <a:gd name="adj" fmla="val 4386"/>
+              <a:gd name="adj" fmla="val 5128"/>
             </a:avLst>
           </a:prstGeom>
           <a:solidFill>
@@ -11695,14 +12011,67 @@
       </p:sp>
       <p:sp>
         <p:nvSpPr>
-          <p:cNvPr id="16" name="Text 14"/>
-          <p:cNvSpPr/>
-          <p:nvPr/>
-        </p:nvSpPr>
-        <p:spPr>
-          <a:xfrm>
-            <a:off x="7452360" y="2148840"/>
-            <a:ext cx="2084832" cy="868680"/>
+          <p:cNvPr id="22" name="Text 20"/>
+          <p:cNvSpPr/>
+          <p:nvPr/>
+        </p:nvSpPr>
+        <p:spPr>
+          <a:xfrm>
+            <a:off x="7772400" y="2121408"/>
+            <a:ext cx="1783080" cy="457200"/>
+          </a:xfrm>
+          <a:prstGeom prst="rect">
+            <a:avLst/>
+          </a:prstGeom>
+          <a:noFill/>
+          <a:ln/>
+        </p:spPr>
+        <p:txBody>
+          <a:bodyPr wrap="square" lIns="0" tIns="0" rIns="0" bIns="0" rtlCol="0" anchor="ctr"/>
+          <a:lstStyle/>
+          <a:p>
+            <a:pPr algn="ctr" indent="0" marL="0">
+              <a:lnSpc>
+                <a:spcPct val="100000"/>
+              </a:lnSpc>
+              <a:buNone/>
+            </a:pPr>
+            <a:r>
+              <a:rPr lang="en-US" sz="1250" b="1" dirty="0">
+                <a:solidFill>
+                  <a:srgbClr val="B85042"/>
+                </a:solidFill>
+              </a:rPr>
+              <a:t>4</a:t>
+            </a:r>
+            <a:pPr algn="ctr" indent="0" marL="0">
+              <a:lnSpc>
+                <a:spcPct val="100000"/>
+              </a:lnSpc>
+              <a:buNone/>
+            </a:pPr>
+            <a:r>
+              <a:rPr lang="en-US" sz="1250" b="1" dirty="0">
+                <a:solidFill>
+                  <a:srgbClr val="1E2761"/>
+                </a:solidFill>
+              </a:rPr>
+              <a:t>  Feature extraction</a:t>
+            </a:r>
+            <a:endParaRPr lang="en-US" sz="1250" dirty="0"/>
+          </a:p>
+        </p:txBody>
+      </p:sp>
+      <p:sp>
+        <p:nvSpPr>
+          <p:cNvPr id="23" name="Text 21"/>
+          <p:cNvSpPr/>
+          <p:nvPr/>
+        </p:nvSpPr>
+        <p:spPr>
+          <a:xfrm>
+            <a:off x="7772400" y="2697480"/>
+            <a:ext cx="1783080" cy="502920"/>
           </a:xfrm>
           <a:prstGeom prst="rect">
             <a:avLst/>
@@ -11718,27 +12087,27 @@
               <a:buNone/>
             </a:pPr>
             <a:r>
-              <a:rPr lang="en-US" sz="1400" b="1" dirty="0">
+              <a:rPr lang="en-US" sz="1800" b="1" dirty="0">
                 <a:solidFill>
                   <a:srgbClr val="1E2761"/>
                 </a:solidFill>
               </a:rPr>
-              <a:t>Feature extraction</a:t>
-            </a:r>
-            <a:endParaRPr lang="en-US" sz="1400" dirty="0"/>
-          </a:p>
-        </p:txBody>
-      </p:sp>
-      <p:sp>
-        <p:nvSpPr>
-          <p:cNvPr id="17" name="Text 15"/>
-          <p:cNvSpPr/>
-          <p:nvPr/>
-        </p:nvSpPr>
-        <p:spPr>
-          <a:xfrm>
-            <a:off x="7525512" y="3063240"/>
-            <a:ext cx="1938528" cy="1463040"/>
+              <a:t>40 features</a:t>
+            </a:r>
+            <a:endParaRPr lang="en-US" sz="1800" dirty="0"/>
+          </a:p>
+        </p:txBody>
+      </p:sp>
+      <p:sp>
+        <p:nvSpPr>
+          <p:cNvPr id="24" name="Text 22"/>
+          <p:cNvSpPr/>
+          <p:nvPr/>
+        </p:nvSpPr>
+        <p:spPr>
+          <a:xfrm>
+            <a:off x="7772400" y="3246120"/>
+            <a:ext cx="1783080" cy="411480"/>
           </a:xfrm>
           <a:prstGeom prst="rect">
             <a:avLst/>
@@ -11751,90 +12120,90 @@
           <a:lstStyle/>
           <a:p>
             <a:pPr algn="ctr" indent="0" marL="0">
-              <a:lnSpc>
-                <a:spcPct val="115000"/>
-              </a:lnSpc>
-              <a:buNone/>
-            </a:pPr>
-            <a:r>
-              <a:rPr lang="en-US" sz="1050" dirty="0">
+              <a:buNone/>
+            </a:pPr>
+            <a:r>
+              <a:rPr lang="en-US" sz="1500" b="1" dirty="0">
+                <a:solidFill>
+                  <a:srgbClr val="B85042"/>
+                </a:solidFill>
+              </a:rPr>
+              <a:t>Q / S / V / T</a:t>
+            </a:r>
+            <a:endParaRPr lang="en-US" sz="1500" dirty="0"/>
+          </a:p>
+        </p:txBody>
+      </p:sp>
+      <p:sp>
+        <p:nvSpPr>
+          <p:cNvPr id="25" name="Text 23"/>
+          <p:cNvSpPr/>
+          <p:nvPr/>
+        </p:nvSpPr>
+        <p:spPr>
+          <a:xfrm>
+            <a:off x="7772400" y="3749040"/>
+            <a:ext cx="1783080" cy="640080"/>
+          </a:xfrm>
+          <a:prstGeom prst="rect">
+            <a:avLst/>
+          </a:prstGeom>
+          <a:noFill/>
+          <a:ln/>
+        </p:spPr>
+        <p:txBody>
+          <a:bodyPr wrap="square" rtlCol="0" anchor="ctr"/>
+          <a:lstStyle/>
+          <a:p>
+            <a:pPr algn="ctr" indent="0" marL="0">
+              <a:lnSpc>
+                <a:spcPct val="105000"/>
+              </a:lnSpc>
+              <a:buNone/>
+            </a:pPr>
+            <a:r>
+              <a:rPr lang="en-US" sz="950" i="1" dirty="0">
                 <a:solidFill>
                   <a:srgbClr val="5A6270"/>
                 </a:solidFill>
               </a:rPr>
-              <a:t>40 features</a:t>
-            </a:r>
-            <a:endParaRPr lang="en-US" sz="1050" dirty="0"/>
+              <a:t>question, section,</a:t>
+            </a:r>
+            <a:endParaRPr lang="en-US" sz="950" dirty="0"/>
           </a:p>
           <a:p>
             <a:pPr algn="ctr" indent="0" marL="0">
               <a:lnSpc>
-                <a:spcPct val="115000"/>
-              </a:lnSpc>
-              <a:buNone/>
-            </a:pPr>
-            <a:r>
-              <a:rPr lang="en-US" sz="1050" dirty="0">
+                <a:spcPct val="105000"/>
+              </a:lnSpc>
+              <a:buNone/>
+            </a:pPr>
+            <a:r>
+              <a:rPr lang="en-US" sz="950" i="1" dirty="0">
                 <a:solidFill>
                   <a:srgbClr val="5A6270"/>
                 </a:solidFill>
               </a:rPr>
-              <a:t>Q / S / V / T groups</a:t>
-            </a:r>
-            <a:endParaRPr lang="en-US" sz="1050" dirty="0"/>
-          </a:p>
-        </p:txBody>
-      </p:sp>
-      <p:sp>
-        <p:nvSpPr>
-          <p:cNvPr id="18" name="Text 16"/>
-          <p:cNvSpPr/>
-          <p:nvPr/>
-        </p:nvSpPr>
-        <p:spPr>
-          <a:xfrm>
-            <a:off x="9482328" y="3063240"/>
-            <a:ext cx="329184" cy="548640"/>
-          </a:xfrm>
-          <a:prstGeom prst="rect">
-            <a:avLst/>
-          </a:prstGeom>
-          <a:noFill/>
-          <a:ln/>
-        </p:spPr>
-        <p:txBody>
-          <a:bodyPr wrap="square" lIns="0" tIns="0" rIns="0" bIns="0" rtlCol="0" anchor="ctr"/>
-          <a:lstStyle/>
-          <a:p>
-            <a:pPr algn="ctr" indent="0" marL="0">
-              <a:buNone/>
-            </a:pPr>
-            <a:r>
-              <a:rPr lang="en-US" sz="2200" b="1" dirty="0">
-                <a:solidFill>
-                  <a:srgbClr val="B85042"/>
-                </a:solidFill>
-              </a:rPr>
-              <a:t>→</a:t>
-            </a:r>
-            <a:endParaRPr lang="en-US" sz="2200" dirty="0"/>
-          </a:p>
-        </p:txBody>
-      </p:sp>
-      <p:sp>
-        <p:nvSpPr>
-          <p:cNvPr id="19" name="Shape 17"/>
-          <p:cNvSpPr/>
-          <p:nvPr/>
-        </p:nvSpPr>
-        <p:spPr>
-          <a:xfrm>
-            <a:off x="9738360" y="2011680"/>
-            <a:ext cx="2084832" cy="2651760"/>
+              <a:t>survey, statistical</a:t>
+            </a:r>
+            <a:endParaRPr lang="en-US" sz="950" dirty="0"/>
+          </a:p>
+        </p:txBody>
+      </p:sp>
+      <p:sp>
+        <p:nvSpPr>
+          <p:cNvPr id="26" name="Shape 24"/>
+          <p:cNvSpPr/>
+          <p:nvPr/>
+        </p:nvSpPr>
+        <p:spPr>
+          <a:xfrm>
+            <a:off x="9829800" y="2011680"/>
+            <a:ext cx="1783080" cy="2651760"/>
           </a:xfrm>
           <a:prstGeom prst="roundRect">
             <a:avLst>
-              <a:gd name="adj" fmla="val 4386"/>
+              <a:gd name="adj" fmla="val 5128"/>
             </a:avLst>
           </a:prstGeom>
           <a:solidFill>
@@ -11845,14 +12214,67 @@
       </p:sp>
       <p:sp>
         <p:nvSpPr>
-          <p:cNvPr id="20" name="Text 18"/>
-          <p:cNvSpPr/>
-          <p:nvPr/>
-        </p:nvSpPr>
-        <p:spPr>
-          <a:xfrm>
-            <a:off x="9738360" y="2148840"/>
-            <a:ext cx="2084832" cy="868680"/>
+          <p:cNvPr id="27" name="Text 25"/>
+          <p:cNvSpPr/>
+          <p:nvPr/>
+        </p:nvSpPr>
+        <p:spPr>
+          <a:xfrm>
+            <a:off x="9829800" y="2121408"/>
+            <a:ext cx="1783080" cy="457200"/>
+          </a:xfrm>
+          <a:prstGeom prst="rect">
+            <a:avLst/>
+          </a:prstGeom>
+          <a:noFill/>
+          <a:ln/>
+        </p:spPr>
+        <p:txBody>
+          <a:bodyPr wrap="square" lIns="0" tIns="0" rIns="0" bIns="0" rtlCol="0" anchor="ctr"/>
+          <a:lstStyle/>
+          <a:p>
+            <a:pPr algn="ctr" indent="0" marL="0">
+              <a:lnSpc>
+                <a:spcPct val="100000"/>
+              </a:lnSpc>
+              <a:buNone/>
+            </a:pPr>
+            <a:r>
+              <a:rPr lang="en-US" sz="1250" b="1" dirty="0">
+                <a:solidFill>
+                  <a:srgbClr val="B85042"/>
+                </a:solidFill>
+              </a:rPr>
+              <a:t>5</a:t>
+            </a:r>
+            <a:pPr algn="ctr" indent="0" marL="0">
+              <a:lnSpc>
+                <a:spcPct val="100000"/>
+              </a:lnSpc>
+              <a:buNone/>
+            </a:pPr>
+            <a:r>
+              <a:rPr lang="en-US" sz="1250" b="1" dirty="0">
+                <a:solidFill>
+                  <a:srgbClr val="1E2761"/>
+                </a:solidFill>
+              </a:rPr>
+              <a:t>  Detection + reporting</a:t>
+            </a:r>
+            <a:endParaRPr lang="en-US" sz="1250" dirty="0"/>
+          </a:p>
+        </p:txBody>
+      </p:sp>
+      <p:sp>
+        <p:nvSpPr>
+          <p:cNvPr id="28" name="Text 26"/>
+          <p:cNvSpPr/>
+          <p:nvPr/>
+        </p:nvSpPr>
+        <p:spPr>
+          <a:xfrm>
+            <a:off x="9829800" y="2724912"/>
+            <a:ext cx="1783080" cy="365760"/>
           </a:xfrm>
           <a:prstGeom prst="rect">
             <a:avLst/>
@@ -11868,27 +12290,27 @@
               <a:buNone/>
             </a:pPr>
             <a:r>
-              <a:rPr lang="en-US" sz="1400" b="1" dirty="0">
+              <a:rPr lang="en-US" sz="1150" b="1" dirty="0">
                 <a:solidFill>
                   <a:srgbClr val="1E2761"/>
                 </a:solidFill>
               </a:rPr>
-              <a:t>Detection + reporting</a:t>
-            </a:r>
-            <a:endParaRPr lang="en-US" sz="1400" dirty="0"/>
-          </a:p>
-        </p:txBody>
-      </p:sp>
-      <p:sp>
-        <p:nvSpPr>
-          <p:cNvPr id="21" name="Text 19"/>
-          <p:cNvSpPr/>
-          <p:nvPr/>
-        </p:nvSpPr>
-        <p:spPr>
-          <a:xfrm>
-            <a:off x="9811512" y="3063240"/>
-            <a:ext cx="1938528" cy="1463040"/>
+              <a:t>IQR fences + rules</a:t>
+            </a:r>
+            <a:endParaRPr lang="en-US" sz="1150" dirty="0"/>
+          </a:p>
+        </p:txBody>
+      </p:sp>
+      <p:sp>
+        <p:nvSpPr>
+          <p:cNvPr id="29" name="Text 27"/>
+          <p:cNvSpPr/>
+          <p:nvPr/>
+        </p:nvSpPr>
+        <p:spPr>
+          <a:xfrm>
+            <a:off x="9902952" y="3200400"/>
+            <a:ext cx="1636776" cy="1188720"/>
           </a:xfrm>
           <a:prstGeom prst="rect">
             <a:avLst/>
@@ -11902,66 +12324,196 @@
           <a:p>
             <a:pPr algn="ctr" indent="0" marL="0">
               <a:lnSpc>
-                <a:spcPct val="115000"/>
-              </a:lnSpc>
+                <a:spcPct val="110000"/>
+              </a:lnSpc>
+              <a:spcAft>
+                <a:spcPts val="400"/>
+              </a:spcAft>
               <a:buNone/>
             </a:pPr>
             <a:r>
               <a:rPr lang="en-US" sz="1050" dirty="0">
                 <a:solidFill>
-                  <a:srgbClr val="5A6270"/>
-                </a:solidFill>
-              </a:rPr>
-              <a:t>IQR fences + rules</a:t>
+                  <a:srgbClr val="1A1A2E"/>
+                </a:solidFill>
+              </a:rPr>
+              <a:t>score, category, flags</a:t>
             </a:r>
             <a:endParaRPr lang="en-US" sz="1050" dirty="0"/>
           </a:p>
           <a:p>
             <a:pPr algn="ctr" indent="0" marL="0">
               <a:lnSpc>
-                <a:spcPct val="115000"/>
+                <a:spcPct val="110000"/>
               </a:lnSpc>
               <a:buNone/>
             </a:pPr>
             <a:r>
               <a:rPr lang="en-US" sz="1050" dirty="0">
                 <a:solidFill>
-                  <a:srgbClr val="5A6270"/>
-                </a:solidFill>
-              </a:rPr>
-              <a:t>score, category, flags</a:t>
+                  <a:srgbClr val="1A1A2E"/>
+                </a:solidFill>
+              </a:rPr>
+              <a:t>CSV reports + metrics</a:t>
             </a:r>
             <a:endParaRPr lang="en-US" sz="1050" dirty="0"/>
           </a:p>
-          <a:p>
-            <a:pPr algn="ctr" indent="0" marL="0">
-              <a:lnSpc>
-                <a:spcPct val="115000"/>
-              </a:lnSpc>
-              <a:buNone/>
-            </a:pPr>
-            <a:r>
-              <a:rPr lang="en-US" sz="1050" dirty="0">
-                <a:solidFill>
-                  <a:srgbClr val="5A6270"/>
-                </a:solidFill>
-              </a:rPr>
-              <a:t>CSV reports + metrics</a:t>
-            </a:r>
-            <a:endParaRPr lang="en-US" sz="1050" dirty="0"/>
-          </a:p>
-        </p:txBody>
-      </p:sp>
-      <p:sp>
-        <p:nvSpPr>
-          <p:cNvPr id="22" name="Text 20"/>
-          <p:cNvSpPr/>
-          <p:nvPr/>
-        </p:nvSpPr>
-        <p:spPr>
-          <a:xfrm>
-            <a:off x="640080" y="5120640"/>
-            <a:ext cx="10972800" cy="731520"/>
+        </p:txBody>
+      </p:sp>
+      <p:sp>
+        <p:nvSpPr>
+          <p:cNvPr id="30" name="Shape 28"/>
+          <p:cNvSpPr/>
+          <p:nvPr/>
+        </p:nvSpPr>
+        <p:spPr>
+          <a:xfrm>
+            <a:off x="2331720" y="2935224"/>
+            <a:ext cx="365760" cy="0"/>
+          </a:xfrm>
+          <a:prstGeom prst="line">
+            <a:avLst/>
+          </a:prstGeom>
+          <a:noFill/>
+          <a:ln w="31750">
+            <a:solidFill>
+              <a:srgbClr val="B85042"/>
+            </a:solidFill>
+            <a:prstDash val="solid"/>
+            <a:tailEnd type="triangle"/>
+          </a:ln>
+        </p:spPr>
+      </p:sp>
+      <p:sp>
+        <p:nvSpPr>
+          <p:cNvPr id="31" name="Shape 29"/>
+          <p:cNvSpPr/>
+          <p:nvPr/>
+        </p:nvSpPr>
+        <p:spPr>
+          <a:xfrm>
+            <a:off x="2331720" y="3685032"/>
+            <a:ext cx="365760" cy="0"/>
+          </a:xfrm>
+          <a:prstGeom prst="line">
+            <a:avLst/>
+          </a:prstGeom>
+          <a:noFill/>
+          <a:ln w="31750">
+            <a:solidFill>
+              <a:srgbClr val="B85042"/>
+            </a:solidFill>
+            <a:prstDash val="solid"/>
+            <a:tailEnd type="triangle"/>
+          </a:ln>
+        </p:spPr>
+      </p:sp>
+      <p:sp>
+        <p:nvSpPr>
+          <p:cNvPr id="32" name="Shape 30"/>
+          <p:cNvSpPr/>
+          <p:nvPr/>
+        </p:nvSpPr>
+        <p:spPr>
+          <a:xfrm>
+            <a:off x="4425696" y="2935224"/>
+            <a:ext cx="512064" cy="219456"/>
+          </a:xfrm>
+          <a:prstGeom prst="line">
+            <a:avLst/>
+          </a:prstGeom>
+          <a:noFill/>
+          <a:ln w="31750">
+            <a:solidFill>
+              <a:srgbClr val="B85042"/>
+            </a:solidFill>
+            <a:prstDash val="solid"/>
+            <a:tailEnd type="triangle"/>
+          </a:ln>
+        </p:spPr>
+      </p:sp>
+      <p:sp>
+        <p:nvSpPr>
+          <p:cNvPr id="33" name="Shape 31"/>
+          <p:cNvSpPr/>
+          <p:nvPr/>
+        </p:nvSpPr>
+        <p:spPr>
+          <a:xfrm flipV="1">
+            <a:off x="4425696" y="3429000"/>
+            <a:ext cx="512064" cy="256032"/>
+          </a:xfrm>
+          <a:prstGeom prst="line">
+            <a:avLst/>
+          </a:prstGeom>
+          <a:noFill/>
+          <a:ln w="31750">
+            <a:solidFill>
+              <a:srgbClr val="B85042"/>
+            </a:solidFill>
+            <a:prstDash val="solid"/>
+            <a:tailEnd type="triangle"/>
+          </a:ln>
+        </p:spPr>
+      </p:sp>
+      <p:sp>
+        <p:nvSpPr>
+          <p:cNvPr id="34" name="Shape 32"/>
+          <p:cNvSpPr/>
+          <p:nvPr/>
+        </p:nvSpPr>
+        <p:spPr>
+          <a:xfrm>
+            <a:off x="7406640" y="3310128"/>
+            <a:ext cx="365760" cy="0"/>
+          </a:xfrm>
+          <a:prstGeom prst="line">
+            <a:avLst/>
+          </a:prstGeom>
+          <a:noFill/>
+          <a:ln w="31750">
+            <a:solidFill>
+              <a:srgbClr val="B85042"/>
+            </a:solidFill>
+            <a:prstDash val="solid"/>
+            <a:tailEnd type="triangle"/>
+          </a:ln>
+        </p:spPr>
+      </p:sp>
+      <p:sp>
+        <p:nvSpPr>
+          <p:cNvPr id="35" name="Shape 33"/>
+          <p:cNvSpPr/>
+          <p:nvPr/>
+        </p:nvSpPr>
+        <p:spPr>
+          <a:xfrm>
+            <a:off x="9555480" y="3310128"/>
+            <a:ext cx="274320" cy="0"/>
+          </a:xfrm>
+          <a:prstGeom prst="line">
+            <a:avLst/>
+          </a:prstGeom>
+          <a:noFill/>
+          <a:ln w="31750">
+            <a:solidFill>
+              <a:srgbClr val="B85042"/>
+            </a:solidFill>
+            <a:prstDash val="solid"/>
+            <a:tailEnd type="triangle"/>
+          </a:ln>
+        </p:spPr>
+      </p:sp>
+      <p:sp>
+        <p:nvSpPr>
+          <p:cNvPr id="36" name="Text 34"/>
+          <p:cNvSpPr/>
+          <p:nvPr/>
+        </p:nvSpPr>
+        <p:spPr>
+          <a:xfrm>
+            <a:off x="640080" y="5212080"/>
+            <a:ext cx="10972800" cy="640080"/>
           </a:xfrm>
           <a:prstGeom prst="rect">
             <a:avLst/>

</xml_diff>

<commit_message>
add learning outcomes slide and Word files
</commit_message>
<xml_diff>
--- a/docs/deliverables/Kaoma_Paradata_Presentation.pptx
+++ b/docs/deliverables/Kaoma_Paradata_Presentation.pptx
@@ -25,6 +25,7 @@
     <p:sldId id="273" r:id="rId19"/>
     <p:sldId id="274" r:id="rId20"/>
     <p:sldId id="275" r:id="rId21"/>
+    <p:sldId id="278" r:id="rId29"/>
     <p:sldId id="276" r:id="rId22"/>
     <p:sldId id="277" r:id="rId23"/>
   </p:sldIdLst>
@@ -7964,6 +7965,769 @@
 </file>
 
 <file path=ppt/slides/slide21.xml><?xml version="1.0" encoding="utf-8"?>
+<p:sld xmlns:a="http://schemas.openxmlformats.org/drawingml/2006/main" xmlns:p="http://schemas.openxmlformats.org/presentationml/2006/main" xmlns:r="http://schemas.openxmlformats.org/officeDocument/2006/relationships">
+  <p:cSld>
+    <p:spTree>
+      <p:nvGrpSpPr>
+        <p:cNvPr id="1" name=""/>
+        <p:cNvGrpSpPr/>
+        <p:nvPr/>
+      </p:nvGrpSpPr>
+      <p:grpSpPr/>
+      <p:sp>
+        <p:nvSpPr>
+          <p:cNvPr id="2" name="Rectangle 1"/>
+          <p:cNvSpPr/>
+          <p:nvPr/>
+        </p:nvSpPr>
+        <p:spPr>
+          <a:xfrm>
+            <a:off x="548640" y="320040"/>
+            <a:ext cx="11064240" cy="731520"/>
+          </a:xfrm>
+          <a:prstGeom prst="rect">
+            <a:avLst/>
+          </a:prstGeom>
+          <a:noFill/>
+          <a:ln>
+            <a:noFill/>
+          </a:ln>
+          <a:effectLst/>
+        </p:spPr>
+        <p:style>
+          <a:lnRef idx="1">
+            <a:schemeClr val="accent1"/>
+          </a:lnRef>
+          <a:fillRef idx="3">
+            <a:schemeClr val="accent1"/>
+          </a:fillRef>
+          <a:effectRef idx="2">
+            <a:schemeClr val="accent1"/>
+          </a:effectRef>
+          <a:fontRef idx="minor">
+            <a:schemeClr val="lt1"/>
+          </a:fontRef>
+        </p:style>
+        <p:txBody>
+          <a:bodyPr rtlCol="0" anchor="ctr" wrap="square" lIns="109728" rIns="109728"/>
+          <a:lstStyle/>
+          <a:p>
+            <a:pPr algn="l"/>
+            <a:r>
+              <a:rPr sz="3000" b="1">
+                <a:solidFill>
+                  <a:srgbClr val="1E2761"/>
+                </a:solidFill>
+                <a:latin typeface="Calibri"/>
+              </a:rPr>
+              <a:t>Mapping to the course learning outcomes</a:t>
+            </a:r>
+          </a:p>
+        </p:txBody>
+      </p:sp>
+      <p:sp>
+        <p:nvSpPr>
+          <p:cNvPr id="3" name="Rectangle 2"/>
+          <p:cNvSpPr/>
+          <p:nvPr/>
+        </p:nvSpPr>
+        <p:spPr>
+          <a:xfrm>
+            <a:off x="640080" y="1234440"/>
+            <a:ext cx="10881360" cy="868680"/>
+          </a:xfrm>
+          <a:prstGeom prst="rect">
+            <a:avLst/>
+          </a:prstGeom>
+          <a:solidFill>
+            <a:srgbClr val="F2F5FB"/>
+          </a:solidFill>
+          <a:ln>
+            <a:noFill/>
+          </a:ln>
+          <a:effectLst/>
+        </p:spPr>
+        <p:style>
+          <a:lnRef idx="1">
+            <a:schemeClr val="accent1"/>
+          </a:lnRef>
+          <a:fillRef idx="3">
+            <a:schemeClr val="accent1"/>
+          </a:fillRef>
+          <a:effectRef idx="2">
+            <a:schemeClr val="accent1"/>
+          </a:effectRef>
+          <a:fontRef idx="minor">
+            <a:schemeClr val="lt1"/>
+          </a:fontRef>
+        </p:style>
+        <p:txBody>
+          <a:bodyPr rtlCol="0" anchor="ctr"/>
+          <a:lstStyle/>
+          <a:p>
+            <a:pPr algn="ctr"/>
+          </a:p>
+        </p:txBody>
+      </p:sp>
+      <p:sp>
+        <p:nvSpPr>
+          <p:cNvPr id="4" name="Rectangle 3"/>
+          <p:cNvSpPr/>
+          <p:nvPr/>
+        </p:nvSpPr>
+        <p:spPr>
+          <a:xfrm>
+            <a:off x="777240" y="1234440"/>
+            <a:ext cx="2743200" cy="868680"/>
+          </a:xfrm>
+          <a:prstGeom prst="rect">
+            <a:avLst/>
+          </a:prstGeom>
+          <a:noFill/>
+          <a:ln>
+            <a:noFill/>
+          </a:ln>
+          <a:effectLst/>
+        </p:spPr>
+        <p:style>
+          <a:lnRef idx="1">
+            <a:schemeClr val="accent1"/>
+          </a:lnRef>
+          <a:fillRef idx="3">
+            <a:schemeClr val="accent1"/>
+          </a:fillRef>
+          <a:effectRef idx="2">
+            <a:schemeClr val="accent1"/>
+          </a:effectRef>
+          <a:fontRef idx="minor">
+            <a:schemeClr val="lt1"/>
+          </a:fontRef>
+        </p:style>
+        <p:txBody>
+          <a:bodyPr rtlCol="0" anchor="ctr" wrap="square" lIns="109728" rIns="109728"/>
+          <a:lstStyle/>
+          <a:p>
+            <a:pPr algn="l"/>
+            <a:r>
+              <a:rPr sz="1300" b="1">
+                <a:solidFill>
+                  <a:srgbClr val="1E2761"/>
+                </a:solidFill>
+                <a:latin typeface="Calibri"/>
+              </a:rPr>
+              <a:t>i.  Concepts, applications
+     and challenges</a:t>
+            </a:r>
+          </a:p>
+        </p:txBody>
+      </p:sp>
+      <p:sp>
+        <p:nvSpPr>
+          <p:cNvPr id="5" name="Rectangle 4"/>
+          <p:cNvSpPr/>
+          <p:nvPr/>
+        </p:nvSpPr>
+        <p:spPr>
+          <a:xfrm>
+            <a:off x="3611880" y="1234440"/>
+            <a:ext cx="7772400" cy="868680"/>
+          </a:xfrm>
+          <a:prstGeom prst="rect">
+            <a:avLst/>
+          </a:prstGeom>
+          <a:noFill/>
+          <a:ln>
+            <a:noFill/>
+          </a:ln>
+          <a:effectLst/>
+        </p:spPr>
+        <p:style>
+          <a:lnRef idx="1">
+            <a:schemeClr val="accent1"/>
+          </a:lnRef>
+          <a:fillRef idx="3">
+            <a:schemeClr val="accent1"/>
+          </a:fillRef>
+          <a:effectRef idx="2">
+            <a:schemeClr val="accent1"/>
+          </a:effectRef>
+          <a:fontRef idx="minor">
+            <a:schemeClr val="lt1"/>
+          </a:fontRef>
+        </p:style>
+        <p:txBody>
+          <a:bodyPr rtlCol="0" anchor="ctr" wrap="square" lIns="109728" rIns="109728"/>
+          <a:lstStyle/>
+          <a:p>
+            <a:pPr algn="l"/>
+            <a:r>
+              <a:rPr sz="1150" b="0">
+                <a:solidFill>
+                  <a:srgbClr val="333A45"/>
+                </a:solidFill>
+                <a:latin typeface="Calibri"/>
+              </a:rPr>
+              <a:t>Literature review covers outlier detection theory and the univariate versus multivariate trade-off. Challenges met and documented rather than asserted: masking under contamination, sensitivity to class imbalance, and feature validity testing.</a:t>
+            </a:r>
+          </a:p>
+        </p:txBody>
+      </p:sp>
+      <p:sp>
+        <p:nvSpPr>
+          <p:cNvPr id="6" name="Rectangle 5"/>
+          <p:cNvSpPr/>
+          <p:nvPr/>
+        </p:nvSpPr>
+        <p:spPr>
+          <a:xfrm>
+            <a:off x="777240" y="2139696"/>
+            <a:ext cx="2743200" cy="868680"/>
+          </a:xfrm>
+          <a:prstGeom prst="rect">
+            <a:avLst/>
+          </a:prstGeom>
+          <a:noFill/>
+          <a:ln>
+            <a:noFill/>
+          </a:ln>
+          <a:effectLst/>
+        </p:spPr>
+        <p:style>
+          <a:lnRef idx="1">
+            <a:schemeClr val="accent1"/>
+          </a:lnRef>
+          <a:fillRef idx="3">
+            <a:schemeClr val="accent1"/>
+          </a:fillRef>
+          <a:effectRef idx="2">
+            <a:schemeClr val="accent1"/>
+          </a:effectRef>
+          <a:fontRef idx="minor">
+            <a:schemeClr val="lt1"/>
+          </a:fontRef>
+        </p:style>
+        <p:txBody>
+          <a:bodyPr rtlCol="0" anchor="ctr" wrap="square" lIns="109728" rIns="109728"/>
+          <a:lstStyle/>
+          <a:p>
+            <a:pPr algn="l"/>
+            <a:r>
+              <a:rPr sz="1300" b="1">
+                <a:solidFill>
+                  <a:srgbClr val="1E2761"/>
+                </a:solidFill>
+                <a:latin typeface="Calibri"/>
+              </a:rPr>
+              <a:t>ii.  Preprocess data</a:t>
+            </a:r>
+          </a:p>
+        </p:txBody>
+      </p:sp>
+      <p:sp>
+        <p:nvSpPr>
+          <p:cNvPr id="7" name="Rectangle 6"/>
+          <p:cNvSpPr/>
+          <p:nvPr/>
+        </p:nvSpPr>
+        <p:spPr>
+          <a:xfrm>
+            <a:off x="3611880" y="2139696"/>
+            <a:ext cx="7772400" cy="868680"/>
+          </a:xfrm>
+          <a:prstGeom prst="rect">
+            <a:avLst/>
+          </a:prstGeom>
+          <a:noFill/>
+          <a:ln>
+            <a:noFill/>
+          </a:ln>
+          <a:effectLst/>
+        </p:spPr>
+        <p:style>
+          <a:lnRef idx="1">
+            <a:schemeClr val="accent1"/>
+          </a:lnRef>
+          <a:fillRef idx="3">
+            <a:schemeClr val="accent1"/>
+          </a:fillRef>
+          <a:effectRef idx="2">
+            <a:schemeClr val="accent1"/>
+          </a:effectRef>
+          <a:fontRef idx="minor">
+            <a:schemeClr val="lt1"/>
+          </a:fontRef>
+        </p:style>
+        <p:txBody>
+          <a:bodyPr rtlCol="0" anchor="ctr" wrap="square" lIns="109728" rIns="109728"/>
+          <a:lstStyle/>
+          <a:p>
+            <a:pPr algn="l"/>
+            <a:r>
+              <a:rPr sz="1150" b="0">
+                <a:solidFill>
+                  <a:srgbClr val="333A45"/>
+                </a:solidFill>
+                <a:latin typeface="Calibri"/>
+              </a:rPr>
+              <a:t>Two platform parsers reduce SurveyCTO and ODK audit logs to one common intermediate representation. Timestamp normalisation across epoch milliseconds and ISO 8601, administrative form rows excluded, ~12,000 raw events reduced to 500 interview-level feature vectors.</a:t>
+            </a:r>
+          </a:p>
+        </p:txBody>
+      </p:sp>
+      <p:sp>
+        <p:nvSpPr>
+          <p:cNvPr id="8" name="Rectangle 7"/>
+          <p:cNvSpPr/>
+          <p:nvPr/>
+        </p:nvSpPr>
+        <p:spPr>
+          <a:xfrm>
+            <a:off x="640080" y="3044952"/>
+            <a:ext cx="10881360" cy="868680"/>
+          </a:xfrm>
+          <a:prstGeom prst="rect">
+            <a:avLst/>
+          </a:prstGeom>
+          <a:solidFill>
+            <a:srgbClr val="F2F5FB"/>
+          </a:solidFill>
+          <a:ln>
+            <a:noFill/>
+          </a:ln>
+          <a:effectLst/>
+        </p:spPr>
+        <p:style>
+          <a:lnRef idx="1">
+            <a:schemeClr val="accent1"/>
+          </a:lnRef>
+          <a:fillRef idx="3">
+            <a:schemeClr val="accent1"/>
+          </a:fillRef>
+          <a:effectRef idx="2">
+            <a:schemeClr val="accent1"/>
+          </a:effectRef>
+          <a:fontRef idx="minor">
+            <a:schemeClr val="lt1"/>
+          </a:fontRef>
+        </p:style>
+        <p:txBody>
+          <a:bodyPr rtlCol="0" anchor="ctr"/>
+          <a:lstStyle/>
+          <a:p>
+            <a:pPr algn="ctr"/>
+          </a:p>
+        </p:txBody>
+      </p:sp>
+      <p:sp>
+        <p:nvSpPr>
+          <p:cNvPr id="9" name="Rectangle 8"/>
+          <p:cNvSpPr/>
+          <p:nvPr/>
+        </p:nvSpPr>
+        <p:spPr>
+          <a:xfrm>
+            <a:off x="777240" y="3044952"/>
+            <a:ext cx="2743200" cy="868680"/>
+          </a:xfrm>
+          <a:prstGeom prst="rect">
+            <a:avLst/>
+          </a:prstGeom>
+          <a:noFill/>
+          <a:ln>
+            <a:noFill/>
+          </a:ln>
+          <a:effectLst/>
+        </p:spPr>
+        <p:style>
+          <a:lnRef idx="1">
+            <a:schemeClr val="accent1"/>
+          </a:lnRef>
+          <a:fillRef idx="3">
+            <a:schemeClr val="accent1"/>
+          </a:fillRef>
+          <a:effectRef idx="2">
+            <a:schemeClr val="accent1"/>
+          </a:effectRef>
+          <a:fontRef idx="minor">
+            <a:schemeClr val="lt1"/>
+          </a:fontRef>
+        </p:style>
+        <p:txBody>
+          <a:bodyPr rtlCol="0" anchor="ctr" wrap="square" lIns="109728" rIns="109728"/>
+          <a:lstStyle/>
+          <a:p>
+            <a:pPr algn="l"/>
+            <a:r>
+              <a:rPr sz="1300" b="1">
+                <a:solidFill>
+                  <a:srgbClr val="1E2761"/>
+                </a:solidFill>
+                <a:latin typeface="Calibri"/>
+              </a:rPr>
+              <a:t>iii.  Implement algorithms</a:t>
+            </a:r>
+          </a:p>
+        </p:txBody>
+      </p:sp>
+      <p:sp>
+        <p:nvSpPr>
+          <p:cNvPr id="10" name="Rectangle 9"/>
+          <p:cNvSpPr/>
+          <p:nvPr/>
+        </p:nvSpPr>
+        <p:spPr>
+          <a:xfrm>
+            <a:off x="3611880" y="3044952"/>
+            <a:ext cx="7772400" cy="868680"/>
+          </a:xfrm>
+          <a:prstGeom prst="rect">
+            <a:avLst/>
+          </a:prstGeom>
+          <a:noFill/>
+          <a:ln>
+            <a:noFill/>
+          </a:ln>
+          <a:effectLst/>
+        </p:spPr>
+        <p:style>
+          <a:lnRef idx="1">
+            <a:schemeClr val="accent1"/>
+          </a:lnRef>
+          <a:fillRef idx="3">
+            <a:schemeClr val="accent1"/>
+          </a:fillRef>
+          <a:effectRef idx="2">
+            <a:schemeClr val="accent1"/>
+          </a:effectRef>
+          <a:fontRef idx="minor">
+            <a:schemeClr val="lt1"/>
+          </a:fontRef>
+        </p:style>
+        <p:txBody>
+          <a:bodyPr rtlCol="0" anchor="ctr" wrap="square" lIns="109728" rIns="109728"/>
+          <a:lstStyle/>
+          <a:p>
+            <a:pPr algn="l"/>
+            <a:r>
+              <a:rPr sz="1150" b="0">
+                <a:solidFill>
+                  <a:srgbClr val="333A45"/>
+                </a:solidFill>
+                <a:latin typeface="Calibri"/>
+              </a:rPr>
+              <a:t>Unsupervised anomaly detection: Tukey IQR fences combined with rule logic, evaluated as binary classification. Mann-Whitney U with Cohen's d for feature validity across all 40 features. Clustering and association rules were outside the project scope.</a:t>
+            </a:r>
+          </a:p>
+        </p:txBody>
+      </p:sp>
+      <p:sp>
+        <p:nvSpPr>
+          <p:cNvPr id="11" name="Rectangle 10"/>
+          <p:cNvSpPr/>
+          <p:nvPr/>
+        </p:nvSpPr>
+        <p:spPr>
+          <a:xfrm>
+            <a:off x="777240" y="3950208"/>
+            <a:ext cx="2743200" cy="868680"/>
+          </a:xfrm>
+          <a:prstGeom prst="rect">
+            <a:avLst/>
+          </a:prstGeom>
+          <a:noFill/>
+          <a:ln>
+            <a:noFill/>
+          </a:ln>
+          <a:effectLst/>
+        </p:spPr>
+        <p:style>
+          <a:lnRef idx="1">
+            <a:schemeClr val="accent1"/>
+          </a:lnRef>
+          <a:fillRef idx="3">
+            <a:schemeClr val="accent1"/>
+          </a:fillRef>
+          <a:effectRef idx="2">
+            <a:schemeClr val="accent1"/>
+          </a:effectRef>
+          <a:fontRef idx="minor">
+            <a:schemeClr val="lt1"/>
+          </a:fontRef>
+        </p:style>
+        <p:txBody>
+          <a:bodyPr rtlCol="0" anchor="ctr" wrap="square" lIns="109728" rIns="109728"/>
+          <a:lstStyle/>
+          <a:p>
+            <a:pPr algn="l"/>
+            <a:r>
+              <a:rPr sz="1300" b="1">
+                <a:solidFill>
+                  <a:srgbClr val="1E2761"/>
+                </a:solidFill>
+                <a:latin typeface="Calibri"/>
+              </a:rPr>
+              <a:t>v.  Evaluate models</a:t>
+            </a:r>
+          </a:p>
+        </p:txBody>
+      </p:sp>
+      <p:sp>
+        <p:nvSpPr>
+          <p:cNvPr id="12" name="Rectangle 11"/>
+          <p:cNvSpPr/>
+          <p:nvPr/>
+        </p:nvSpPr>
+        <p:spPr>
+          <a:xfrm>
+            <a:off x="3611880" y="3950208"/>
+            <a:ext cx="7772400" cy="868680"/>
+          </a:xfrm>
+          <a:prstGeom prst="rect">
+            <a:avLst/>
+          </a:prstGeom>
+          <a:noFill/>
+          <a:ln>
+            <a:noFill/>
+          </a:ln>
+          <a:effectLst/>
+        </p:spPr>
+        <p:style>
+          <a:lnRef idx="1">
+            <a:schemeClr val="accent1"/>
+          </a:lnRef>
+          <a:fillRef idx="3">
+            <a:schemeClr val="accent1"/>
+          </a:fillRef>
+          <a:effectRef idx="2">
+            <a:schemeClr val="accent1"/>
+          </a:effectRef>
+          <a:fontRef idx="minor">
+            <a:schemeClr val="lt1"/>
+          </a:fontRef>
+        </p:style>
+        <p:txBody>
+          <a:bodyPr rtlCol="0" anchor="ctr" wrap="square" lIns="109728" rIns="109728"/>
+          <a:lstStyle/>
+          <a:p>
+            <a:pPr algn="l"/>
+            <a:r>
+              <a:rPr sz="1150" b="0">
+                <a:solidFill>
+                  <a:srgbClr val="333A45"/>
+                </a:solidFill>
+                <a:latin typeface="Calibri"/>
+              </a:rPr>
+              <a:t>Precision, recall, F1, accuracy and specificity against labelled ground truth. Two named baselines. Class imbalance sweep from 5 to 30 percent prevalence. Scalability measured from 500 to 10,000 interviews.</a:t>
+            </a:r>
+          </a:p>
+        </p:txBody>
+      </p:sp>
+      <p:sp>
+        <p:nvSpPr>
+          <p:cNvPr id="13" name="Rectangle 12"/>
+          <p:cNvSpPr/>
+          <p:nvPr/>
+        </p:nvSpPr>
+        <p:spPr>
+          <a:xfrm>
+            <a:off x="640080" y="4855464"/>
+            <a:ext cx="10881360" cy="868680"/>
+          </a:xfrm>
+          <a:prstGeom prst="rect">
+            <a:avLst/>
+          </a:prstGeom>
+          <a:solidFill>
+            <a:srgbClr val="F2F5FB"/>
+          </a:solidFill>
+          <a:ln>
+            <a:noFill/>
+          </a:ln>
+          <a:effectLst/>
+        </p:spPr>
+        <p:style>
+          <a:lnRef idx="1">
+            <a:schemeClr val="accent1"/>
+          </a:lnRef>
+          <a:fillRef idx="3">
+            <a:schemeClr val="accent1"/>
+          </a:fillRef>
+          <a:effectRef idx="2">
+            <a:schemeClr val="accent1"/>
+          </a:effectRef>
+          <a:fontRef idx="minor">
+            <a:schemeClr val="lt1"/>
+          </a:fontRef>
+        </p:style>
+        <p:txBody>
+          <a:bodyPr rtlCol="0" anchor="ctr"/>
+          <a:lstStyle/>
+          <a:p>
+            <a:pPr algn="ctr"/>
+          </a:p>
+        </p:txBody>
+      </p:sp>
+      <p:sp>
+        <p:nvSpPr>
+          <p:cNvPr id="14" name="Rectangle 13"/>
+          <p:cNvSpPr/>
+          <p:nvPr/>
+        </p:nvSpPr>
+        <p:spPr>
+          <a:xfrm>
+            <a:off x="777240" y="4855464"/>
+            <a:ext cx="2743200" cy="868680"/>
+          </a:xfrm>
+          <a:prstGeom prst="rect">
+            <a:avLst/>
+          </a:prstGeom>
+          <a:noFill/>
+          <a:ln>
+            <a:noFill/>
+          </a:ln>
+          <a:effectLst/>
+        </p:spPr>
+        <p:style>
+          <a:lnRef idx="1">
+            <a:schemeClr val="accent1"/>
+          </a:lnRef>
+          <a:fillRef idx="3">
+            <a:schemeClr val="accent1"/>
+          </a:fillRef>
+          <a:effectRef idx="2">
+            <a:schemeClr val="accent1"/>
+          </a:effectRef>
+          <a:fontRef idx="minor">
+            <a:schemeClr val="lt1"/>
+          </a:fontRef>
+        </p:style>
+        <p:txBody>
+          <a:bodyPr rtlCol="0" anchor="ctr" wrap="square" lIns="109728" rIns="109728"/>
+          <a:lstStyle/>
+          <a:p>
+            <a:pPr algn="l"/>
+            <a:r>
+              <a:rPr sz="1300" b="1">
+                <a:solidFill>
+                  <a:srgbClr val="1E2761"/>
+                </a:solidFill>
+                <a:latin typeface="Calibri"/>
+              </a:rPr>
+              <a:t>vi.  Apply tools</a:t>
+            </a:r>
+          </a:p>
+        </p:txBody>
+      </p:sp>
+      <p:sp>
+        <p:nvSpPr>
+          <p:cNvPr id="15" name="Rectangle 14"/>
+          <p:cNvSpPr/>
+          <p:nvPr/>
+        </p:nvSpPr>
+        <p:spPr>
+          <a:xfrm>
+            <a:off x="3611880" y="4855464"/>
+            <a:ext cx="7772400" cy="868680"/>
+          </a:xfrm>
+          <a:prstGeom prst="rect">
+            <a:avLst/>
+          </a:prstGeom>
+          <a:noFill/>
+          <a:ln>
+            <a:noFill/>
+          </a:ln>
+          <a:effectLst/>
+        </p:spPr>
+        <p:style>
+          <a:lnRef idx="1">
+            <a:schemeClr val="accent1"/>
+          </a:lnRef>
+          <a:fillRef idx="3">
+            <a:schemeClr val="accent1"/>
+          </a:fillRef>
+          <a:effectRef idx="2">
+            <a:schemeClr val="accent1"/>
+          </a:effectRef>
+          <a:fontRef idx="minor">
+            <a:schemeClr val="lt1"/>
+          </a:fontRef>
+        </p:style>
+        <p:txBody>
+          <a:bodyPr rtlCol="0" anchor="ctr" wrap="square" lIns="109728" rIns="109728"/>
+          <a:lstStyle/>
+          <a:p>
+            <a:pPr algn="l"/>
+            <a:r>
+              <a:rPr sz="1150" b="0">
+                <a:solidFill>
+                  <a:srgbClr val="333A45"/>
+                </a:solidFill>
+                <a:latin typeface="Calibri"/>
+              </a:rPr>
+              <a:t>Python throughout: pandas, NumPy, SciPy, statsmodels, scikit-learn, pytest, with continuous integration on two library versions. Weka and RapidMiner were not used.</a:t>
+            </a:r>
+          </a:p>
+        </p:txBody>
+      </p:sp>
+      <p:sp>
+        <p:nvSpPr>
+          <p:cNvPr id="16" name="Rectangle 15"/>
+          <p:cNvSpPr/>
+          <p:nvPr/>
+        </p:nvSpPr>
+        <p:spPr>
+          <a:xfrm>
+            <a:off x="640080" y="5870448"/>
+            <a:ext cx="10881360" cy="502920"/>
+          </a:xfrm>
+          <a:prstGeom prst="rect">
+            <a:avLst/>
+          </a:prstGeom>
+          <a:noFill/>
+          <a:ln>
+            <a:noFill/>
+          </a:ln>
+          <a:effectLst/>
+        </p:spPr>
+        <p:style>
+          <a:lnRef idx="1">
+            <a:schemeClr val="accent1"/>
+          </a:lnRef>
+          <a:fillRef idx="3">
+            <a:schemeClr val="accent1"/>
+          </a:fillRef>
+          <a:effectRef idx="2">
+            <a:schemeClr val="accent1"/>
+          </a:effectRef>
+          <a:fontRef idx="minor">
+            <a:schemeClr val="lt1"/>
+          </a:fontRef>
+        </p:style>
+        <p:txBody>
+          <a:bodyPr rtlCol="0" anchor="ctr" wrap="square" lIns="109728" rIns="109728"/>
+          <a:lstStyle/>
+          <a:p>
+            <a:pPr algn="l"/>
+            <a:r>
+              <a:rPr sz="1250" b="1">
+                <a:solidFill>
+                  <a:srgbClr val="B85042"/>
+                </a:solidFill>
+                <a:latin typeface="Calibri"/>
+              </a:rPr>
+              <a:t>Outcome iv is addressed in part: the parser pipeline is an ETL design, though no OLAP cube or star schema was built.  Outcome vii is covered on the ethics slide.</a:t>
+            </a:r>
+          </a:p>
+        </p:txBody>
+      </p:sp>
+    </p:spTree>
+  </p:cSld>
+  <p:clrMapOvr>
+    <a:masterClrMapping/>
+  </p:clrMapOvr>
+</p:sld>
+</file>
+
+<file path=ppt/slides/slide22.xml><?xml version="1.0" encoding="utf-8"?>
 <p:sld xmlns:a="http://schemas.openxmlformats.org/drawingml/2006/main" xmlns:r="http://schemas.openxmlformats.org/officeDocument/2006/relationships" xmlns:p="http://schemas.openxmlformats.org/presentationml/2006/main">
   <p:cSld name="Slide 21">
     <p:bg>
@@ -7995,8 +8759,8 @@
         </p:nvSpPr>
         <p:spPr>
           <a:xfrm>
-            <a:off x="822960" y="640080"/>
-            <a:ext cx="10515600" cy="731520"/>
+            <a:off x="548640" y="320040"/>
+            <a:ext cx="11064240" cy="731520"/>
           </a:xfrm>
           <a:prstGeom prst="rect">
             <a:avLst/>
@@ -8472,7 +9236,7 @@
 </p:sld>
 </file>
 
-<file path=ppt/slides/slide22.xml><?xml version="1.0" encoding="utf-8"?>
+<file path=ppt/slides/slide23.xml><?xml version="1.0" encoding="utf-8"?>
 <p:sld xmlns:a="http://schemas.openxmlformats.org/drawingml/2006/main" xmlns:r="http://schemas.openxmlformats.org/officeDocument/2006/relationships" xmlns:p="http://schemas.openxmlformats.org/presentationml/2006/main">
   <p:cSld name="Slide 22">
     <p:bg>

</xml_diff>